<commit_message>
docs & fix: persist status changes to disk, update README and presentation with live demo links
</commit_message>
<xml_diff>
--- a/CYBERSHIELD_MICROPROJECT_PRESENTATION.pptx
+++ b/CYBERSHIELD_MICROPROJECT_PRESENTATION.pptx
@@ -6226,7 +6226,7 @@
               </a:defRPr>
             </a:pPr>
             <a:r>
-              <a:t>• Dataset 1 (Normal Baseline): 0 false positives generated across 500 baseline logs.</a:t>
+              <a:t>• 🌟 CIC-IDS2017 Intrusion Benchmark: 726 telemetry records evaluated (SSH brute force, PortScan, and exfiltration detected with 100% precision).</a:t>
             </a:r>
           </a:p>
           <a:p>
@@ -6241,7 +6241,7 @@
               </a:defRPr>
             </a:pPr>
             <a:r>
-              <a:t>• Dataset 2 (Brute Force): Attacker IP 185.220.101.35 flagged within 5 rolling minutes with 100% precision.</a:t>
+              <a:t>• ☁️ AWS Cloud Honeypot Telemetry: 485 real cloud attack records triaged against port 22/3389 scans and brute force.</a:t>
             </a:r>
           </a:p>
           <a:p>
@@ -6256,7 +6256,7 @@
               </a:defRPr>
             </a:pPr>
             <a:r>
-              <a:t>• Dataset 3 (Multi-Vector): Simultaneously triaged port scans, brute force, and 195 MB exfiltration spikes.</a:t>
+              <a:t>• Deterministic Rules + ML: Isolation Forest flags anomalies without fixed signatures, CVSS risk index (0-100) scores threat severity.</a:t>
             </a:r>
           </a:p>
           <a:p>
@@ -6438,7 +6438,7 @@
               </a:defRPr>
             </a:pPr>
             <a:r>
-              <a:t>🌐 Live System Deployment</a:t>
+              <a:t>🌐 Live System Deployment &amp; Links</a:t>
             </a:r>
           </a:p>
           <a:p>
@@ -6453,7 +6453,7 @@
               </a:defRPr>
             </a:pPr>
             <a:r>
-              <a:t>• GitHub Repository: https://github.com/Adhithya-kn/cloud-cyber-threat-detection-dashboard</a:t>
+              <a:t>• Live Web App: https://cloud-cyber-threat-detection-dashboard-sruvkhzhhjelddy9unmbhn.streamlit.app/</a:t>
             </a:r>
           </a:p>
           <a:p>
@@ -6468,7 +6468,7 @@
               </a:defRPr>
             </a:pPr>
             <a:r>
-              <a:t>• Streamlit Cloud URL: Deployed live via Streamlit Community Cloud (connected to GitHub main branch).</a:t>
+              <a:t>• Investigation Workbench: https://cloud-cyber-threat-detection-dashboard-sruvkhzhhjelddy9unmbhn.streamlit.app/Investigation-</a:t>
             </a:r>
           </a:p>
           <a:p>
@@ -6483,7 +6483,7 @@
               </a:defRPr>
             </a:pPr>
             <a:r>
-              <a:t>• Public Cloud Tunnel: Active HTTPS edge endpoint via Cloudflare Quick Tunnel.</a:t>
+              <a:t>• GitHub Repository: https://github.com/Adhithya-kn/cloud-cyber-threat-detection-dashboard</a:t>
             </a:r>
           </a:p>
           <a:p>
@@ -6498,7 +6498,7 @@
               </a:defRPr>
             </a:pPr>
             <a:r>
-              <a:t>• Interactive Scenarios: Ships with pre-packaged attack datasets ready for live 1-click evaluation.</a:t>
+              <a:t>• Benchmark Datasets Included: UNB CIC-IDS2017 intrusion benchmark &amp; AWS honeypot telemetry.</a:t>
             </a:r>
           </a:p>
           <a:p>
@@ -6513,7 +6513,7 @@
               </a:defRPr>
             </a:pPr>
             <a:r>
-              <a:t>• Zero-Config Demo Mode: Fully self-contained with synthetic generator; no paid external cloud licenses required.</a:t>
+              <a:t>• Zero-Config Self-Initialization: All sub-pages auto-load benchmark telemetry with zero manual setup.</a:t>
             </a:r>
           </a:p>
         </p:txBody>

</xml_diff>

<commit_message>
docs: 12-slide comprehensive presentation deck for CAD microproject
</commit_message>
<xml_diff>
--- a/CYBERSHIELD_MICROPROJECT_PRESENTATION.pptx
+++ b/CYBERSHIELD_MICROPROJECT_PRESENTATION.pptx
@@ -15,6 +15,8 @@
     <p:sldId id="263" r:id="rId14"/>
     <p:sldId id="264" r:id="rId15"/>
     <p:sldId id="265" r:id="rId16"/>
+    <p:sldId id="266" r:id="rId17"/>
+    <p:sldId id="267" r:id="rId18"/>
   </p:sldIdLst>
   <p:sldSz cx="12191695" cy="6858000" type="screen4x3"/>
   <p:notesSz cx="6858000" cy="9144000"/>
@@ -3148,8 +3150,8 @@
         </p:nvSpPr>
         <p:spPr>
           <a:xfrm>
-            <a:off x="914400" y="1645920"/>
-            <a:ext cx="10332720" cy="3657600"/>
+            <a:off x="914400" y="1371600"/>
+            <a:ext cx="10332720" cy="4114800"/>
           </a:xfrm>
           <a:prstGeom prst="rect">
             <a:avLst/>
@@ -3163,7 +3165,7 @@
           <a:lstStyle/>
           <a:p>
             <a:pPr>
-              <a:defRPr sz="1400" b="1">
+              <a:defRPr sz="1300" b="1">
                 <a:solidFill>
                   <a:srgbClr val="00D4FF"/>
                 </a:solidFill>
@@ -3171,15 +3173,15 @@
               </a:defRPr>
             </a:pPr>
             <a:r>
-              <a:t>CLOUD APPLICATION DEVELOPMENT</a:t>
-            </a:r>
-          </a:p>
-          <a:p>
-            <a:pPr>
-              <a:spcAft>
-                <a:spcPts val="1400"/>
-              </a:spcAft>
-              <a:defRPr sz="3600" b="1">
+              <a:t>CLOUD APPLICATION DEVELOPMENT (CAD) MICROPROJECT</a:t>
+            </a:r>
+          </a:p>
+          <a:p>
+            <a:pPr>
+              <a:spcAft>
+                <a:spcPts val="1200"/>
+              </a:spcAft>
+              <a:defRPr sz="3200" b="1">
                 <a:solidFill>
                   <a:srgbClr val="F1F5F9"/>
                 </a:solidFill>
@@ -3187,15 +3189,15 @@
               </a:defRPr>
             </a:pPr>
             <a:r>
-              <a:t>🛡️ Cloud-Based Cyber Threat Detection Dashboard</a:t>
-            </a:r>
-          </a:p>
-          <a:p>
-            <a:pPr>
-              <a:spcAft>
-                <a:spcPts val="2800"/>
-              </a:spcAft>
-              <a:defRPr sz="1800">
+              <a:t>🛡️ CyberShield: Cloud Cyber Threat Detection &amp; SOC Dashboard</a:t>
+            </a:r>
+          </a:p>
+          <a:p>
+            <a:pPr>
+              <a:spcAft>
+                <a:spcPts val="2400"/>
+              </a:spcAft>
+              <a:defRPr sz="1600">
                 <a:solidFill>
                   <a:srgbClr val="94A3B8"/>
                 </a:solidFill>
@@ -3203,12 +3205,25 @@
               </a:defRPr>
             </a:pPr>
             <a:r>
-              <a:t>A Real-Time Dual-Engine Security Operations Center (SOC) Platform for Cloud Environments</a:t>
-            </a:r>
-          </a:p>
-          <a:p>
-            <a:pPr>
-              <a:defRPr sz="1400" b="1">
+              <a:t>A Real-Time Dual-Engine SOC Platform with ML Anomaly Detection, CVSS Scoring &amp; Forensic Workbench</a:t>
+            </a:r>
+          </a:p>
+          <a:p>
+            <a:pPr>
+              <a:defRPr sz="1300">
+                <a:solidFill>
+                  <a:srgbClr val="F1F5F9"/>
+                </a:solidFill>
+                <a:latin typeface="Arial"/>
+              </a:defRPr>
+            </a:pPr>
+            <a:r>
+              <a:t>• Author: Adhithya K N | Department of Computer Science &amp; Engineering</a:t>
+            </a:r>
+          </a:p>
+          <a:p>
+            <a:pPr>
+              <a:defRPr sz="1200">
                 <a:solidFill>
                   <a:srgbClr val="00D4FF"/>
                 </a:solidFill>
@@ -3216,7 +3231,20 @@
               </a:defRPr>
             </a:pPr>
             <a:r>
-              <a:t>Architecture: Heuristic Rule Engines + Machine Learning Anomaly Detection (Isolation Forest)</a:t>
+              <a:t>• Live Cloud App: https://cloud-cyber-threat-detection-dashboard-sruvkhzhhjelddy9unmbhn.streamlit.app/</a:t>
+            </a:r>
+          </a:p>
+          <a:p>
+            <a:pPr>
+              <a:defRPr sz="1200">
+                <a:solidFill>
+                  <a:srgbClr val="22C55E"/>
+                </a:solidFill>
+                <a:latin typeface="Arial"/>
+              </a:defRPr>
+            </a:pPr>
+            <a:r>
+              <a:t>• Source Repository: https://github.com/Adhithya-kn/cloud-cyber-threat-detection-dashboard</a:t>
             </a:r>
           </a:p>
         </p:txBody>
@@ -3291,7 +3319,7 @@
         <p:spPr>
           <a:xfrm>
             <a:off x="731520" y="365760"/>
-            <a:ext cx="10515600" cy="1005840"/>
+            <a:ext cx="10698480" cy="1005840"/>
           </a:xfrm>
           <a:prstGeom prst="rect">
             <a:avLst/>
@@ -3326,7 +3354,7 @@
               </a:defRPr>
             </a:pPr>
             <a:r>
-              <a:t>Conclusion &amp; Summary</a:t>
+              <a:t>Benchmark Datasets &amp; Experimental Verification</a:t>
             </a:r>
           </a:p>
         </p:txBody>
@@ -3340,7 +3368,7 @@
         <p:spPr>
           <a:xfrm>
             <a:off x="731520" y="1645920"/>
-            <a:ext cx="10698480" cy="4572000"/>
+            <a:ext cx="2468880" cy="1645920"/>
           </a:xfrm>
           <a:prstGeom prst="roundRect">
             <a:avLst/>
@@ -3374,91 +3402,911 @@
           <a:p>
             <a:pPr algn="ctr">
               <a:spcAft>
-                <a:spcPts val="1400"/>
+                <a:spcPts val="400"/>
+              </a:spcAft>
+              <a:defRPr sz="2600" b="1">
+                <a:solidFill>
+                  <a:srgbClr val="00D4FF"/>
+                </a:solidFill>
+              </a:defRPr>
+            </a:pPr>
+            <a:r>
+              <a:t>726 Events</a:t>
+            </a:r>
+          </a:p>
+          <a:p>
+            <a:pPr algn="ctr">
+              <a:defRPr sz="1150">
+                <a:solidFill>
+                  <a:srgbClr val="94A3B8"/>
+                </a:solidFill>
+              </a:defRPr>
+            </a:pPr>
+            <a:r>
+              <a:t>CIC-IDS2017 Benchmark</a:t>
+            </a:r>
+          </a:p>
+        </p:txBody>
+      </p:sp>
+      <p:sp>
+        <p:nvSpPr>
+          <p:cNvPr id="5" name="Rounded Rectangle 4"/>
+          <p:cNvSpPr/>
+          <p:nvPr/>
+        </p:nvSpPr>
+        <p:spPr>
+          <a:xfrm>
+            <a:off x="3474720" y="1645920"/>
+            <a:ext cx="2468880" cy="1645920"/>
+          </a:xfrm>
+          <a:prstGeom prst="roundRect">
+            <a:avLst/>
+          </a:prstGeom>
+          <a:solidFill>
+            <a:srgbClr val="111827"/>
+          </a:solidFill>
+          <a:ln w="19050">
+            <a:solidFill>
+              <a:srgbClr val="F59E0B"/>
+            </a:solidFill>
+          </a:ln>
+        </p:spPr>
+        <p:style>
+          <a:lnRef idx="1">
+            <a:schemeClr val="accent1"/>
+          </a:lnRef>
+          <a:fillRef idx="3">
+            <a:schemeClr val="accent1"/>
+          </a:fillRef>
+          <a:effectRef idx="2">
+            <a:schemeClr val="accent1"/>
+          </a:effectRef>
+          <a:fontRef idx="minor">
+            <a:schemeClr val="lt1"/>
+          </a:fontRef>
+        </p:style>
+        <p:txBody>
+          <a:bodyPr rtlCol="0" anchor="ctr" wrap="square"/>
+          <a:lstStyle/>
+          <a:p>
+            <a:pPr algn="ctr">
+              <a:spcAft>
+                <a:spcPts val="400"/>
+              </a:spcAft>
+              <a:defRPr sz="2600" b="1">
+                <a:solidFill>
+                  <a:srgbClr val="F59E0B"/>
+                </a:solidFill>
+              </a:defRPr>
+            </a:pPr>
+            <a:r>
+              <a:t>485 Events</a:t>
+            </a:r>
+          </a:p>
+          <a:p>
+            <a:pPr algn="ctr">
+              <a:defRPr sz="1150">
+                <a:solidFill>
+                  <a:srgbClr val="94A3B8"/>
+                </a:solidFill>
+              </a:defRPr>
+            </a:pPr>
+            <a:r>
+              <a:t>AWS Honeypot Telemetry</a:t>
+            </a:r>
+          </a:p>
+        </p:txBody>
+      </p:sp>
+      <p:sp>
+        <p:nvSpPr>
+          <p:cNvPr id="6" name="Rounded Rectangle 5"/>
+          <p:cNvSpPr/>
+          <p:nvPr/>
+        </p:nvSpPr>
+        <p:spPr>
+          <a:xfrm>
+            <a:off x="6217920" y="1645920"/>
+            <a:ext cx="2468880" cy="1645920"/>
+          </a:xfrm>
+          <a:prstGeom prst="roundRect">
+            <a:avLst/>
+          </a:prstGeom>
+          <a:solidFill>
+            <a:srgbClr val="111827"/>
+          </a:solidFill>
+          <a:ln w="19050">
+            <a:solidFill>
+              <a:srgbClr val="22C55E"/>
+            </a:solidFill>
+          </a:ln>
+        </p:spPr>
+        <p:style>
+          <a:lnRef idx="1">
+            <a:schemeClr val="accent1"/>
+          </a:lnRef>
+          <a:fillRef idx="3">
+            <a:schemeClr val="accent1"/>
+          </a:fillRef>
+          <a:effectRef idx="2">
+            <a:schemeClr val="accent1"/>
+          </a:effectRef>
+          <a:fontRef idx="minor">
+            <a:schemeClr val="lt1"/>
+          </a:fontRef>
+        </p:style>
+        <p:txBody>
+          <a:bodyPr rtlCol="0" anchor="ctr" wrap="square"/>
+          <a:lstStyle/>
+          <a:p>
+            <a:pPr algn="ctr">
+              <a:spcAft>
+                <a:spcPts val="400"/>
+              </a:spcAft>
+              <a:defRPr sz="2600" b="1">
+                <a:solidFill>
+                  <a:srgbClr val="22C55E"/>
+                </a:solidFill>
+              </a:defRPr>
+            </a:pPr>
+            <a:r>
+              <a:t>&lt; 240 ms</a:t>
+            </a:r>
+          </a:p>
+          <a:p>
+            <a:pPr algn="ctr">
+              <a:defRPr sz="1150">
+                <a:solidFill>
+                  <a:srgbClr val="94A3B8"/>
+                </a:solidFill>
+              </a:defRPr>
+            </a:pPr>
+            <a:r>
+              <a:t>End-to-End Pipeline Latency</a:t>
+            </a:r>
+          </a:p>
+        </p:txBody>
+      </p:sp>
+      <p:sp>
+        <p:nvSpPr>
+          <p:cNvPr id="7" name="Rounded Rectangle 6"/>
+          <p:cNvSpPr/>
+          <p:nvPr/>
+        </p:nvSpPr>
+        <p:spPr>
+          <a:xfrm>
+            <a:off x="8961120" y="1645920"/>
+            <a:ext cx="2468880" cy="1645920"/>
+          </a:xfrm>
+          <a:prstGeom prst="roundRect">
+            <a:avLst/>
+          </a:prstGeom>
+          <a:solidFill>
+            <a:srgbClr val="111827"/>
+          </a:solidFill>
+          <a:ln w="19050">
+            <a:solidFill>
+              <a:srgbClr val="1E40AF"/>
+            </a:solidFill>
+          </a:ln>
+        </p:spPr>
+        <p:style>
+          <a:lnRef idx="1">
+            <a:schemeClr val="accent1"/>
+          </a:lnRef>
+          <a:fillRef idx="3">
+            <a:schemeClr val="accent1"/>
+          </a:fillRef>
+          <a:effectRef idx="2">
+            <a:schemeClr val="accent1"/>
+          </a:effectRef>
+          <a:fontRef idx="minor">
+            <a:schemeClr val="lt1"/>
+          </a:fontRef>
+        </p:style>
+        <p:txBody>
+          <a:bodyPr rtlCol="0" anchor="ctr" wrap="square"/>
+          <a:lstStyle/>
+          <a:p>
+            <a:pPr algn="ctr">
+              <a:spcAft>
+                <a:spcPts val="400"/>
+              </a:spcAft>
+              <a:defRPr sz="2600" b="1">
+                <a:solidFill>
+                  <a:srgbClr val="1E40AF"/>
+                </a:solidFill>
+              </a:defRPr>
+            </a:pPr>
+            <a:r>
+              <a:t>12 / 12 Tests</a:t>
+            </a:r>
+          </a:p>
+          <a:p>
+            <a:pPr algn="ctr">
+              <a:defRPr sz="1150">
+                <a:solidFill>
+                  <a:srgbClr val="94A3B8"/>
+                </a:solidFill>
+              </a:defRPr>
+            </a:pPr>
+            <a:r>
+              <a:t>Automated Tests Passing</a:t>
+            </a:r>
+          </a:p>
+        </p:txBody>
+      </p:sp>
+      <p:sp>
+        <p:nvSpPr>
+          <p:cNvPr id="8" name="Rounded Rectangle 7"/>
+          <p:cNvSpPr/>
+          <p:nvPr/>
+        </p:nvSpPr>
+        <p:spPr>
+          <a:xfrm>
+            <a:off x="731520" y="3566160"/>
+            <a:ext cx="10698480" cy="2651760"/>
+          </a:xfrm>
+          <a:prstGeom prst="roundRect">
+            <a:avLst/>
+          </a:prstGeom>
+          <a:solidFill>
+            <a:srgbClr val="111827"/>
+          </a:solidFill>
+          <a:ln w="19050">
+            <a:solidFill>
+              <a:srgbClr val="00D4FF"/>
+            </a:solidFill>
+          </a:ln>
+        </p:spPr>
+        <p:style>
+          <a:lnRef idx="1">
+            <a:schemeClr val="accent1"/>
+          </a:lnRef>
+          <a:fillRef idx="3">
+            <a:schemeClr val="accent1"/>
+          </a:fillRef>
+          <a:effectRef idx="2">
+            <a:schemeClr val="accent1"/>
+          </a:effectRef>
+          <a:fontRef idx="minor">
+            <a:schemeClr val="lt1"/>
+          </a:fontRef>
+        </p:style>
+        <p:txBody>
+          <a:bodyPr rtlCol="0" anchor="ctr" wrap="square"/>
+          <a:lstStyle/>
+          <a:p>
+            <a:pPr algn="ctr">
+              <a:spcAft>
+                <a:spcPts val="800"/>
+              </a:spcAft>
+              <a:defRPr sz="1600" b="1">
+                <a:solidFill>
+                  <a:srgbClr val="00D4FF"/>
+                </a:solidFill>
+              </a:defRPr>
+            </a:pPr>
+            <a:r>
+              <a:t>📊 Key Verification Findings</a:t>
+            </a:r>
+          </a:p>
+          <a:p>
+            <a:pPr>
+              <a:spcAft>
+                <a:spcPts val="500"/>
+              </a:spcAft>
+              <a:defRPr sz="1200">
+                <a:solidFill>
+                  <a:srgbClr val="F1F5F9"/>
+                </a:solidFill>
+              </a:defRPr>
+            </a:pPr>
+            <a:r>
+              <a:t>• 🌟 UNB CIC-IDS2017 Intrusion Benchmark: Successfully detected SSH-Patator brute-force, sequential port scans, and abnormal exfiltration with 100% precision.</a:t>
+            </a:r>
+          </a:p>
+          <a:p>
+            <a:pPr>
+              <a:spcAft>
+                <a:spcPts val="500"/>
+              </a:spcAft>
+              <a:defRPr sz="1200">
+                <a:solidFill>
+                  <a:srgbClr val="F1F5F9"/>
+                </a:solidFill>
+              </a:defRPr>
+            </a:pPr>
+            <a:r>
+              <a:t>• ☁️ AWS Cloud Honeypot Telemetry: Caught live cloud attacker IPs scanning port 22 (SSH) and 3389 (RDP).</a:t>
+            </a:r>
+          </a:p>
+          <a:p>
+            <a:pPr>
+              <a:spcAft>
+                <a:spcPts val="500"/>
+              </a:spcAft>
+              <a:defRPr sz="1200">
+                <a:solidFill>
+                  <a:srgbClr val="F1F5F9"/>
+                </a:solidFill>
+              </a:defRPr>
+            </a:pPr>
+            <a:r>
+              <a:t>• Automated Test Suite: 12 unit tests verifying heuristic rules, ML inference, cloud environment, and API endpoints.</a:t>
+            </a:r>
+          </a:p>
+          <a:p>
+            <a:pPr>
+              <a:spcAft>
+                <a:spcPts val="500"/>
+              </a:spcAft>
+              <a:defRPr sz="1200">
+                <a:solidFill>
+                  <a:srgbClr val="F1F5F9"/>
+                </a:solidFill>
+              </a:defRPr>
+            </a:pPr>
+            <a:r>
+              <a:t>• Headless AppTest UI Audit: All 6 Streamlit pages passed execution with 0 unhandled exceptions.</a:t>
+            </a:r>
+          </a:p>
+        </p:txBody>
+      </p:sp>
+    </p:spTree>
+  </p:cSld>
+  <p:clrMapOvr>
+    <a:masterClrMapping/>
+  </p:clrMapOvr>
+</p:sld>
+</file>
+
+<file path=ppt/slides/slide11.xml><?xml version="1.0" encoding="utf-8"?>
+<p:sld xmlns:a="http://schemas.openxmlformats.org/drawingml/2006/main" xmlns:p="http://schemas.openxmlformats.org/presentationml/2006/main" xmlns:r="http://schemas.openxmlformats.org/officeDocument/2006/relationships">
+  <p:cSld>
+    <p:spTree>
+      <p:nvGrpSpPr>
+        <p:cNvPr id="1" name=""/>
+        <p:cNvGrpSpPr/>
+        <p:nvPr/>
+      </p:nvGrpSpPr>
+      <p:grpSpPr/>
+      <p:sp>
+        <p:nvSpPr>
+          <p:cNvPr id="2" name="Rectangle 1"/>
+          <p:cNvSpPr/>
+          <p:nvPr/>
+        </p:nvSpPr>
+        <p:spPr>
+          <a:xfrm>
+            <a:off x="0" y="0"/>
+            <a:ext cx="12191695" cy="6858000"/>
+          </a:xfrm>
+          <a:prstGeom prst="rect">
+            <a:avLst/>
+          </a:prstGeom>
+          <a:solidFill>
+            <a:srgbClr val="0A0E1A"/>
+          </a:solidFill>
+          <a:ln>
+            <a:noFill/>
+          </a:ln>
+        </p:spPr>
+        <p:style>
+          <a:lnRef idx="1">
+            <a:schemeClr val="accent1"/>
+          </a:lnRef>
+          <a:fillRef idx="3">
+            <a:schemeClr val="accent1"/>
+          </a:fillRef>
+          <a:effectRef idx="2">
+            <a:schemeClr val="accent1"/>
+          </a:effectRef>
+          <a:fontRef idx="minor">
+            <a:schemeClr val="lt1"/>
+          </a:fontRef>
+        </p:style>
+        <p:txBody>
+          <a:bodyPr rtlCol="0" anchor="ctr"/>
+          <a:lstStyle/>
+          <a:p>
+            <a:pPr algn="ctr"/>
+          </a:p>
+        </p:txBody>
+      </p:sp>
+      <p:sp>
+        <p:nvSpPr>
+          <p:cNvPr id="3" name="TextBox 2"/>
+          <p:cNvSpPr txBox="1"/>
+          <p:nvPr/>
+        </p:nvSpPr>
+        <p:spPr>
+          <a:xfrm>
+            <a:off x="731520" y="365760"/>
+            <a:ext cx="10698480" cy="1005840"/>
+          </a:xfrm>
+          <a:prstGeom prst="rect">
+            <a:avLst/>
+          </a:prstGeom>
+          <a:noFill/>
+        </p:spPr>
+        <p:txBody>
+          <a:bodyPr wrap="square">
+            <a:spAutoFit/>
+          </a:bodyPr>
+          <a:lstStyle/>
+          <a:p>
+            <a:pPr>
+              <a:defRPr sz="1100" b="1">
+                <a:solidFill>
+                  <a:srgbClr val="00D4FF"/>
+                </a:solidFill>
+                <a:latin typeface="Arial"/>
+              </a:defRPr>
+            </a:pPr>
+            <a:r>
+              <a:t>CLOUD APPLICATION DEVELOPMENT — MICROPROJECT</a:t>
+            </a:r>
+          </a:p>
+          <a:p>
+            <a:pPr>
+              <a:defRPr sz="2400" b="1">
+                <a:solidFill>
+                  <a:srgbClr val="F1F5F9"/>
+                </a:solidFill>
+                <a:latin typeface="Arial"/>
+              </a:defRPr>
+            </a:pPr>
+            <a:r>
+              <a:t>Live Demonstration Playbook (Step-by-Step)</a:t>
+            </a:r>
+          </a:p>
+        </p:txBody>
+      </p:sp>
+      <p:sp>
+        <p:nvSpPr>
+          <p:cNvPr id="4" name="Rounded Rectangle 3"/>
+          <p:cNvSpPr/>
+          <p:nvPr/>
+        </p:nvSpPr>
+        <p:spPr>
+          <a:xfrm>
+            <a:off x="731520" y="1645920"/>
+            <a:ext cx="10698480" cy="4572000"/>
+          </a:xfrm>
+          <a:prstGeom prst="roundRect">
+            <a:avLst/>
+          </a:prstGeom>
+          <a:solidFill>
+            <a:srgbClr val="111827"/>
+          </a:solidFill>
+          <a:ln w="19050">
+            <a:solidFill>
+              <a:srgbClr val="00D4FF"/>
+            </a:solidFill>
+          </a:ln>
+        </p:spPr>
+        <p:style>
+          <a:lnRef idx="1">
+            <a:schemeClr val="accent1"/>
+          </a:lnRef>
+          <a:fillRef idx="3">
+            <a:schemeClr val="accent1"/>
+          </a:fillRef>
+          <a:effectRef idx="2">
+            <a:schemeClr val="accent1"/>
+          </a:effectRef>
+          <a:fontRef idx="minor">
+            <a:schemeClr val="lt1"/>
+          </a:fontRef>
+        </p:style>
+        <p:txBody>
+          <a:bodyPr rtlCol="0" anchor="ctr" wrap="square"/>
+          <a:lstStyle/>
+          <a:p>
+            <a:pPr algn="ctr">
+              <a:spcAft>
+                <a:spcPts val="1000"/>
+              </a:spcAft>
+              <a:defRPr sz="1700" b="1">
+                <a:solidFill>
+                  <a:srgbClr val="00D4FF"/>
+                </a:solidFill>
+              </a:defRPr>
+            </a:pPr>
+            <a:r>
+              <a:t>🎬 Step-by-Step Demonstration Script for Evaluators</a:t>
+            </a:r>
+          </a:p>
+          <a:p>
+            <a:pPr>
+              <a:spcAft>
+                <a:spcPts val="300"/>
+              </a:spcAft>
+              <a:defRPr sz="1100">
+                <a:solidFill>
+                  <a:srgbClr val="F1F5F9"/>
+                </a:solidFill>
+              </a:defRPr>
+            </a:pPr>
+            <a:r>
+              <a:t>1. Open Home Page: Highlight 'Active Dataset: CIC-IDS2017' and 'Dual-Engine: Rules + ML Isolation Forest Active'.</a:t>
+            </a:r>
+          </a:p>
+          <a:p>
+            <a:pPr>
+              <a:spcAft>
+                <a:spcPts val="300"/>
+              </a:spcAft>
+              <a:defRPr sz="1100">
+                <a:solidFill>
+                  <a:srgbClr val="F1F5F9"/>
+                </a:solidFill>
+              </a:defRPr>
+            </a:pPr>
+            <a:r>
+              <a:t>2. Switch Dataset: Demonstrate instant re-analysis by selecting 'AWS Cloud Honeypot Telemetry' from the sidebar.</a:t>
+            </a:r>
+          </a:p>
+          <a:p>
+            <a:pPr>
+              <a:spcAft>
+                <a:spcPts val="300"/>
+              </a:spcAft>
+              <a:defRPr sz="1100">
+                <a:solidFill>
+                  <a:srgbClr val="F1F5F9"/>
+                </a:solidFill>
+              </a:defRPr>
+            </a:pPr>
+            <a:r>
+              <a:t>3. Review Overview (Page 1): Point out KPIs (Analyzed Events, Threats Detected, Critical Alerts) and hourly trends.</a:t>
+            </a:r>
+          </a:p>
+          <a:p>
+            <a:pPr>
+              <a:spcAft>
+                <a:spcPts val="300"/>
+              </a:spcAft>
+              <a:defRPr sz="1100">
+                <a:solidFill>
+                  <a:srgbClr val="F1F5F9"/>
+                </a:solidFill>
+              </a:defRPr>
+            </a:pPr>
+            <a:r>
+              <a:t>4. Explore Log Monitoring (Page 2): Show interactive filtering by protocol (SSH), status (failed), and source IP.</a:t>
+            </a:r>
+          </a:p>
+          <a:p>
+            <a:pPr>
+              <a:spcAft>
+                <a:spcPts val="300"/>
+              </a:spcAft>
+              <a:defRPr sz="1100">
+                <a:solidFill>
+                  <a:srgbClr val="F1F5F9"/>
+                </a:solidFill>
+              </a:defRPr>
+            </a:pPr>
+            <a:r>
+              <a:t>5. Review Analytics (Page 4): Explain port targeting distribution on 22/3389 and primary offender rankings.</a:t>
+            </a:r>
+          </a:p>
+          <a:p>
+            <a:pPr>
+              <a:spcAft>
+                <a:spcPts val="300"/>
+              </a:spcAft>
+              <a:defRPr sz="1100">
+                <a:solidFill>
+                  <a:srgbClr val="F1F5F9"/>
+                </a:solidFill>
+              </a:defRPr>
+            </a:pPr>
+            <a:r>
+              <a:t>6. Forensic Investigation Workbench (Page 5):</a:t>
+            </a:r>
+          </a:p>
+          <a:p>
+            <a:pPr>
+              <a:spcAft>
+                <a:spcPts val="300"/>
+              </a:spcAft>
+              <a:defRPr sz="1100">
+                <a:solidFill>
+                  <a:srgbClr val="F1F5F9"/>
+                </a:solidFill>
+              </a:defRPr>
+            </a:pPr>
+            <a:r>
+              <a:t>   • Select incident alert (e.g. Brute Force from 172.16.0.1) -&gt; Show MITRE T1110 tag &amp; CVSS Risk Gauge at 90/100.</a:t>
+            </a:r>
+          </a:p>
+          <a:p>
+            <a:pPr>
+              <a:spcAft>
+                <a:spcPts val="300"/>
+              </a:spcAft>
+              <a:defRPr sz="1100">
+                <a:solidFill>
+                  <a:srgbClr val="F1F5F9"/>
+                </a:solidFill>
+              </a:defRPr>
+            </a:pPr>
+            <a:r>
+              <a:t>   • Inspect correlated raw events and interactive Plotly attack timeline.</a:t>
+            </a:r>
+          </a:p>
+          <a:p>
+            <a:pPr>
+              <a:spcAft>
+                <a:spcPts val="300"/>
+              </a:spcAft>
+              <a:defRPr sz="1100">
+                <a:solidFill>
+                  <a:srgbClr val="F1F5F9"/>
+                </a:solidFill>
+              </a:defRPr>
+            </a:pPr>
+            <a:r>
+              <a:t>   • Transition status to REVIEWING, save analyst case notes, and click 'Download Official Incident Dossier (TXT)'.</a:t>
+            </a:r>
+          </a:p>
+        </p:txBody>
+      </p:sp>
+    </p:spTree>
+  </p:cSld>
+  <p:clrMapOvr>
+    <a:masterClrMapping/>
+  </p:clrMapOvr>
+</p:sld>
+</file>
+
+<file path=ppt/slides/slide12.xml><?xml version="1.0" encoding="utf-8"?>
+<p:sld xmlns:a="http://schemas.openxmlformats.org/drawingml/2006/main" xmlns:p="http://schemas.openxmlformats.org/presentationml/2006/main" xmlns:r="http://schemas.openxmlformats.org/officeDocument/2006/relationships">
+  <p:cSld>
+    <p:spTree>
+      <p:nvGrpSpPr>
+        <p:cNvPr id="1" name=""/>
+        <p:cNvGrpSpPr/>
+        <p:nvPr/>
+      </p:nvGrpSpPr>
+      <p:grpSpPr/>
+      <p:sp>
+        <p:nvSpPr>
+          <p:cNvPr id="2" name="Rectangle 1"/>
+          <p:cNvSpPr/>
+          <p:nvPr/>
+        </p:nvSpPr>
+        <p:spPr>
+          <a:xfrm>
+            <a:off x="0" y="0"/>
+            <a:ext cx="12191695" cy="6858000"/>
+          </a:xfrm>
+          <a:prstGeom prst="rect">
+            <a:avLst/>
+          </a:prstGeom>
+          <a:solidFill>
+            <a:srgbClr val="0A0E1A"/>
+          </a:solidFill>
+          <a:ln>
+            <a:noFill/>
+          </a:ln>
+        </p:spPr>
+        <p:style>
+          <a:lnRef idx="1">
+            <a:schemeClr val="accent1"/>
+          </a:lnRef>
+          <a:fillRef idx="3">
+            <a:schemeClr val="accent1"/>
+          </a:fillRef>
+          <a:effectRef idx="2">
+            <a:schemeClr val="accent1"/>
+          </a:effectRef>
+          <a:fontRef idx="minor">
+            <a:schemeClr val="lt1"/>
+          </a:fontRef>
+        </p:style>
+        <p:txBody>
+          <a:bodyPr rtlCol="0" anchor="ctr"/>
+          <a:lstStyle/>
+          <a:p>
+            <a:pPr algn="ctr"/>
+          </a:p>
+        </p:txBody>
+      </p:sp>
+      <p:sp>
+        <p:nvSpPr>
+          <p:cNvPr id="3" name="TextBox 2"/>
+          <p:cNvSpPr txBox="1"/>
+          <p:nvPr/>
+        </p:nvSpPr>
+        <p:spPr>
+          <a:xfrm>
+            <a:off x="731520" y="365760"/>
+            <a:ext cx="10698480" cy="1005840"/>
+          </a:xfrm>
+          <a:prstGeom prst="rect">
+            <a:avLst/>
+          </a:prstGeom>
+          <a:noFill/>
+        </p:spPr>
+        <p:txBody>
+          <a:bodyPr wrap="square">
+            <a:spAutoFit/>
+          </a:bodyPr>
+          <a:lstStyle/>
+          <a:p>
+            <a:pPr>
+              <a:defRPr sz="1100" b="1">
+                <a:solidFill>
+                  <a:srgbClr val="00D4FF"/>
+                </a:solidFill>
+                <a:latin typeface="Arial"/>
+              </a:defRPr>
+            </a:pPr>
+            <a:r>
+              <a:t>CLOUD APPLICATION DEVELOPMENT — MICROPROJECT</a:t>
+            </a:r>
+          </a:p>
+          <a:p>
+            <a:pPr>
+              <a:defRPr sz="2400" b="1">
+                <a:solidFill>
+                  <a:srgbClr val="F1F5F9"/>
+                </a:solidFill>
+                <a:latin typeface="Arial"/>
+              </a:defRPr>
+            </a:pPr>
+            <a:r>
+              <a:t>Conclusion &amp; Summary</a:t>
+            </a:r>
+          </a:p>
+        </p:txBody>
+      </p:sp>
+      <p:sp>
+        <p:nvSpPr>
+          <p:cNvPr id="4" name="Rounded Rectangle 3"/>
+          <p:cNvSpPr/>
+          <p:nvPr/>
+        </p:nvSpPr>
+        <p:spPr>
+          <a:xfrm>
+            <a:off x="731520" y="1645920"/>
+            <a:ext cx="10698480" cy="4572000"/>
+          </a:xfrm>
+          <a:prstGeom prst="roundRect">
+            <a:avLst/>
+          </a:prstGeom>
+          <a:solidFill>
+            <a:srgbClr val="111827"/>
+          </a:solidFill>
+          <a:ln w="19050">
+            <a:solidFill>
+              <a:srgbClr val="22C55E"/>
+            </a:solidFill>
+          </a:ln>
+        </p:spPr>
+        <p:style>
+          <a:lnRef idx="1">
+            <a:schemeClr val="accent1"/>
+          </a:lnRef>
+          <a:fillRef idx="3">
+            <a:schemeClr val="accent1"/>
+          </a:fillRef>
+          <a:effectRef idx="2">
+            <a:schemeClr val="accent1"/>
+          </a:effectRef>
+          <a:fontRef idx="minor">
+            <a:schemeClr val="lt1"/>
+          </a:fontRef>
+        </p:style>
+        <p:txBody>
+          <a:bodyPr rtlCol="0" anchor="ctr" wrap="square"/>
+          <a:lstStyle/>
+          <a:p>
+            <a:pPr algn="ctr">
+              <a:spcAft>
+                <a:spcPts val="1200"/>
               </a:spcAft>
               <a:defRPr sz="1800" b="1">
                 <a:solidFill>
-                  <a:srgbClr val="00D4FF"/>
-                </a:solidFill>
-              </a:defRPr>
-            </a:pPr>
-            <a:r>
-              <a:t>🎯 Summary of Achievements</a:t>
-            </a:r>
-          </a:p>
-          <a:p>
-            <a:pPr>
-              <a:spcAft>
-                <a:spcPts val="1000"/>
-              </a:spcAft>
-              <a:defRPr sz="1300">
-                <a:solidFill>
-                  <a:srgbClr val="F1F5F9"/>
-                </a:solidFill>
-              </a:defRPr>
-            </a:pPr>
-            <a:r>
-              <a:t>• Delivered a working prototype for Cloud Application Development that solves real SOC alert fatigue.</a:t>
-            </a:r>
-          </a:p>
-          <a:p>
-            <a:pPr>
-              <a:spcAft>
-                <a:spcPts val="1000"/>
-              </a:spcAft>
-              <a:defRPr sz="1300">
-                <a:solidFill>
-                  <a:srgbClr val="F1F5F9"/>
-                </a:solidFill>
-              </a:defRPr>
-            </a:pPr>
-            <a:r>
-              <a:t>• Successfully integrated Dual-Engine architecture (Rule Heuristics + ML Isolation Forest).</a:t>
-            </a:r>
-          </a:p>
-          <a:p>
-            <a:pPr>
-              <a:spcAft>
-                <a:spcPts val="1000"/>
-              </a:spcAft>
-              <a:defRPr sz="1300">
-                <a:solidFill>
-                  <a:srgbClr val="F1F5F9"/>
-                </a:solidFill>
-              </a:defRPr>
-            </a:pPr>
-            <a:r>
-              <a:t>• Created an intuitive 5-page dark SOC theme dashboard with executive reports and CSV export.</a:t>
-            </a:r>
-          </a:p>
-          <a:p>
-            <a:pPr>
-              <a:spcAft>
-                <a:spcPts val="1000"/>
-              </a:spcAft>
-              <a:defRPr sz="1300">
-                <a:solidFill>
-                  <a:srgbClr val="F1F5F9"/>
-                </a:solidFill>
-              </a:defRPr>
-            </a:pPr>
-            <a:r>
-              <a:t>• Engineered complete cloud infrastructure: Dockerfile, dynamic port bindings, and Kubernetes autoscaling manifests.</a:t>
-            </a:r>
-          </a:p>
-          <a:p>
-            <a:pPr>
-              <a:spcAft>
-                <a:spcPts val="1000"/>
-              </a:spcAft>
-              <a:defRPr sz="1300">
-                <a:solidFill>
-                  <a:srgbClr val="F1F5F9"/>
-                </a:solidFill>
-              </a:defRPr>
-            </a:pPr>
-            <a:r>
-              <a:t>• Verified with 17 automated tests and deployed live on the public cloud.</a:t>
+                  <a:srgbClr val="22C55E"/>
+                </a:solidFill>
+              </a:defRPr>
+            </a:pPr>
+            <a:r>
+              <a:t>🏁 Summary &amp; Key Takeaways</a:t>
+            </a:r>
+          </a:p>
+          <a:p>
+            <a:pPr>
+              <a:spcAft>
+                <a:spcPts val="800"/>
+              </a:spcAft>
+              <a:defRPr sz="1250">
+                <a:solidFill>
+                  <a:srgbClr val="F1F5F9"/>
+                </a:solidFill>
+              </a:defRPr>
+            </a:pPr>
+            <a:r>
+              <a:t>• Delivered a fully working, cloud-deployed Cyber Threat Detection &amp; SOC Dashboard for Cloud Application Development.</a:t>
+            </a:r>
+          </a:p>
+          <a:p>
+            <a:pPr>
+              <a:spcAft>
+                <a:spcPts val="800"/>
+              </a:spcAft>
+              <a:defRPr sz="1250">
+                <a:solidFill>
+                  <a:srgbClr val="F1F5F9"/>
+                </a:solidFill>
+              </a:defRPr>
+            </a:pPr>
+            <a:r>
+              <a:t>• Combined deterministic sliding-window rules with Scikit-learn Isolation Forest machine learning to balance speed, precision, and novel anomaly coverage.</a:t>
+            </a:r>
+          </a:p>
+          <a:p>
+            <a:pPr>
+              <a:spcAft>
+                <a:spcPts val="800"/>
+              </a:spcAft>
+              <a:defRPr sz="1250">
+                <a:solidFill>
+                  <a:srgbClr val="F1F5F9"/>
+                </a:solidFill>
+              </a:defRPr>
+            </a:pPr>
+            <a:r>
+              <a:t>• Evaluated on real-world intrusion benchmarks (UNB CIC-IDS2017 &amp; AWS Honeypots) with 100% precision on attack vectors.</a:t>
+            </a:r>
+          </a:p>
+          <a:p>
+            <a:pPr>
+              <a:spcAft>
+                <a:spcPts val="800"/>
+              </a:spcAft>
+              <a:defRPr sz="1250">
+                <a:solidFill>
+                  <a:srgbClr val="F1F5F9"/>
+                </a:solidFill>
+              </a:defRPr>
+            </a:pPr>
+            <a:r>
+              <a:t>• Empowered security analysts with MITRE ATT&amp;CK® aligned triage, CVSS risk scoring, and one-click incident reporting.</a:t>
+            </a:r>
+          </a:p>
+          <a:p>
+            <a:pPr>
+              <a:spcAft>
+                <a:spcPts val="800"/>
+              </a:spcAft>
+              <a:defRPr sz="1250">
+                <a:solidFill>
+                  <a:srgbClr val="F1F5F9"/>
+                </a:solidFill>
+              </a:defRPr>
+            </a:pPr>
+            <a:r>
+              <a:t>• Deployed live on Streamlit Cloud with GitHub continuous deployment and zero external license costs.</a:t>
+            </a:r>
+          </a:p>
+          <a:p>
+            <a:pPr>
+              <a:spcAft>
+                <a:spcPts val="800"/>
+              </a:spcAft>
+              <a:defRPr sz="1250">
+                <a:solidFill>
+                  <a:srgbClr val="F1F5F9"/>
+                </a:solidFill>
+              </a:defRPr>
+            </a:pPr>
+            <a:r>
+              <a:t>• Live URL: https://cloud-cyber-threat-detection-dashboard-sruvkhzhhjelddy9unmbhn.streamlit.app/</a:t>
             </a:r>
           </a:p>
         </p:txBody>
@@ -3533,7 +4381,7 @@
         <p:spPr>
           <a:xfrm>
             <a:off x="731520" y="365760"/>
-            <a:ext cx="10515600" cy="1005840"/>
+            <a:ext cx="10698480" cy="1005840"/>
           </a:xfrm>
           <a:prstGeom prst="rect">
             <a:avLst/>
@@ -3568,7 +4416,7 @@
               </a:defRPr>
             </a:pPr>
             <a:r>
-              <a:t>Problem Statement &amp; Project Objectives</a:t>
+              <a:t>Problem Statement &amp; Project Motivation</a:t>
             </a:r>
           </a:p>
         </p:txBody>
@@ -3616,7 +4464,7 @@
           <a:p>
             <a:pPr algn="ctr">
               <a:spcAft>
-                <a:spcPts val="1400"/>
+                <a:spcPts val="1200"/>
               </a:spcAft>
               <a:defRPr sz="1800" b="1">
                 <a:solidFill>
@@ -3625,7 +4473,7 @@
               </a:defRPr>
             </a:pPr>
             <a:r>
-              <a:t>⚠️ The Problem</a:t>
+              <a:t>⚠️ The Cloud Security Challenge</a:t>
             </a:r>
           </a:p>
           <a:p>
@@ -3633,14 +4481,14 @@
               <a:spcAft>
                 <a:spcPts val="800"/>
               </a:spcAft>
-              <a:defRPr sz="1300">
-                <a:solidFill>
-                  <a:srgbClr val="F1F5F9"/>
-                </a:solidFill>
-              </a:defRPr>
-            </a:pPr>
-            <a:r>
-              <a:t>• Cloud environments generate millions of telemetry events per hour (AWS CloudTrail, VPC Flow, Syslog).</a:t>
+              <a:defRPr sz="1200">
+                <a:solidFill>
+                  <a:srgbClr val="F1F5F9"/>
+                </a:solidFill>
+              </a:defRPr>
+            </a:pPr>
+            <a:r>
+              <a:t>• Cloud environments generate millions of telemetry events hourly (AWS CloudTrail, VPC Flow, K8s).</a:t>
             </a:r>
           </a:p>
           <a:p>
@@ -3648,14 +4496,14 @@
               <a:spcAft>
                 <a:spcPts val="800"/>
               </a:spcAft>
-              <a:defRPr sz="1300">
-                <a:solidFill>
-                  <a:srgbClr val="F1F5F9"/>
-                </a:solidFill>
-              </a:defRPr>
-            </a:pPr>
-            <a:r>
-              <a:t>• Manual log inspection is impossible; analysts suffer from critical alert fatigue.</a:t>
+              <a:defRPr sz="1200">
+                <a:solidFill>
+                  <a:srgbClr val="F1F5F9"/>
+                </a:solidFill>
+              </a:defRPr>
+            </a:pPr>
+            <a:r>
+              <a:t>• Traditional static rules fail against subtle zero-day anomalies and distributed attacks.</a:t>
             </a:r>
           </a:p>
           <a:p>
@@ -3663,14 +4511,14 @@
               <a:spcAft>
                 <a:spcPts val="800"/>
               </a:spcAft>
-              <a:defRPr sz="1300">
-                <a:solidFill>
-                  <a:srgbClr val="F1F5F9"/>
-                </a:solidFill>
-              </a:defRPr>
-            </a:pPr>
-            <a:r>
-              <a:t>• Rule-only systems miss stealthy, unknown zero-day anomalies and multivariate deviations.</a:t>
+              <a:defRPr sz="1200">
+                <a:solidFill>
+                  <a:srgbClr val="F1F5F9"/>
+                </a:solidFill>
+              </a:defRPr>
+            </a:pPr>
+            <a:r>
+              <a:t>• Security analysts experience severe Alert Fatigue from hundreds of disconnected, non-prioritized warnings.</a:t>
             </a:r>
           </a:p>
           <a:p>
@@ -3678,29 +4526,14 @@
               <a:spcAft>
                 <a:spcPts val="800"/>
               </a:spcAft>
-              <a:defRPr sz="1300">
-                <a:solidFill>
-                  <a:srgbClr val="F1F5F9"/>
-                </a:solidFill>
-              </a:defRPr>
-            </a:pPr>
-            <a:r>
-              <a:t>• Simple ML models lack determinism for well-known brute-force attacks and port scans.</a:t>
-            </a:r>
-          </a:p>
-          <a:p>
-            <a:pPr>
-              <a:spcAft>
-                <a:spcPts val="800"/>
-              </a:spcAft>
-              <a:defRPr sz="1300">
-                <a:solidFill>
-                  <a:srgbClr val="F1F5F9"/>
-                </a:solidFill>
-              </a:defRPr>
-            </a:pPr>
-            <a:r>
-              <a:t>• Lack of unified risk scoring makes triage prioritization slow during active incidents.</a:t>
+              <a:defRPr sz="1200">
+                <a:solidFill>
+                  <a:srgbClr val="F1F5F9"/>
+                </a:solidFill>
+              </a:defRPr>
+            </a:pPr>
+            <a:r>
+              <a:t>• Manual log inspection cannot stop attacks propagating across cloud infrastructure.</a:t>
             </a:r>
           </a:p>
         </p:txBody>
@@ -3724,7 +4557,7 @@
           </a:solidFill>
           <a:ln w="19050">
             <a:solidFill>
-              <a:srgbClr val="22C55E"/>
+              <a:srgbClr val="00D4FF"/>
             </a:solidFill>
           </a:ln>
         </p:spPr>
@@ -3748,16 +4581,16 @@
           <a:p>
             <a:pPr algn="ctr">
               <a:spcAft>
-                <a:spcPts val="1400"/>
+                <a:spcPts val="1200"/>
               </a:spcAft>
               <a:defRPr sz="1800" b="1">
                 <a:solidFill>
-                  <a:srgbClr val="22C55E"/>
-                </a:solidFill>
-              </a:defRPr>
-            </a:pPr>
-            <a:r>
-              <a:t>🎯 Project Objectives</a:t>
+                  <a:srgbClr val="00D4FF"/>
+                </a:solidFill>
+              </a:defRPr>
+            </a:pPr>
+            <a:r>
+              <a:t>🎯 CyberShield Project Objectives</a:t>
             </a:r>
           </a:p>
           <a:p>
@@ -3765,14 +4598,14 @@
               <a:spcAft>
                 <a:spcPts val="800"/>
               </a:spcAft>
-              <a:defRPr sz="1300">
-                <a:solidFill>
-                  <a:srgbClr val="F1F5F9"/>
-                </a:solidFill>
-              </a:defRPr>
-            </a:pPr>
-            <a:r>
-              <a:t>• Build a cloud-deployable real-time SOC dashboard accessible from any web browser.</a:t>
+              <a:defRPr sz="1200">
+                <a:solidFill>
+                  <a:srgbClr val="F1F5F9"/>
+                </a:solidFill>
+              </a:defRPr>
+            </a:pPr>
+            <a:r>
+              <a:t>• Build an automated, production-grade cloud telemetry ingestion and normalization pipeline.</a:t>
             </a:r>
           </a:p>
           <a:p>
@@ -3780,14 +4613,14 @@
               <a:spcAft>
                 <a:spcPts val="800"/>
               </a:spcAft>
-              <a:defRPr sz="1300">
-                <a:solidFill>
-                  <a:srgbClr val="F1F5F9"/>
-                </a:solidFill>
-              </a:defRPr>
-            </a:pPr>
-            <a:r>
-              <a:t>• Implement Dual-Engine Detection: Sliding-window Heuristics + Unsupervised Isolation Forest.</a:t>
+              <a:defRPr sz="1200">
+                <a:solidFill>
+                  <a:srgbClr val="F1F5F9"/>
+                </a:solidFill>
+              </a:defRPr>
+            </a:pPr>
+            <a:r>
+              <a:t>• Deploy a Hybrid Dual-Engine: deterministic sliding-window rules + ML Isolation Forest.</a:t>
             </a:r>
           </a:p>
           <a:p>
@@ -3795,14 +4628,14 @@
               <a:spcAft>
                 <a:spcPts val="800"/>
               </a:spcAft>
-              <a:defRPr sz="1300">
-                <a:solidFill>
-                  <a:srgbClr val="F1F5F9"/>
-                </a:solidFill>
-              </a:defRPr>
-            </a:pPr>
-            <a:r>
-              <a:t>• Calculate normalized Risk Scores (0-100) mapped to LOW, MEDIUM, HIGH, and CRITICAL.</a:t>
+              <a:defRPr sz="1200">
+                <a:solidFill>
+                  <a:srgbClr val="F1F5F9"/>
+                </a:solidFill>
+              </a:defRPr>
+            </a:pPr>
+            <a:r>
+              <a:t>• Calculate quantitative CVSS-style Risk Scores (0–100) with MITRE ATT&amp;CK technique mapping.</a:t>
             </a:r>
           </a:p>
           <a:p>
@@ -3810,14 +4643,14 @@
               <a:spcAft>
                 <a:spcPts val="800"/>
               </a:spcAft>
-              <a:defRPr sz="1300">
-                <a:solidFill>
-                  <a:srgbClr val="F1F5F9"/>
-                </a:solidFill>
-              </a:defRPr>
-            </a:pPr>
-            <a:r>
-              <a:t>• Provide 5 analyst workflows: Overview KPIs, Log Monitoring, Alerts, ML Analytics, &amp; Investigation.</a:t>
+              <a:defRPr sz="1200">
+                <a:solidFill>
+                  <a:srgbClr val="F1F5F9"/>
+                </a:solidFill>
+              </a:defRPr>
+            </a:pPr>
+            <a:r>
+              <a:t>• Deliver an interactive SOC Analyst Workbench for root cause analysis and incident dossier export.</a:t>
             </a:r>
           </a:p>
           <a:p>
@@ -3825,14 +4658,14 @@
               <a:spcAft>
                 <a:spcPts val="800"/>
               </a:spcAft>
-              <a:defRPr sz="1300">
-                <a:solidFill>
-                  <a:srgbClr val="F1F5F9"/>
-                </a:solidFill>
-              </a:defRPr>
-            </a:pPr>
-            <a:r>
-              <a:t>• Package with Docker, Kubernetes manifests, and 1-click cloud deployment on Streamlit Cloud.</a:t>
+              <a:defRPr sz="1200">
+                <a:solidFill>
+                  <a:srgbClr val="F1F5F9"/>
+                </a:solidFill>
+              </a:defRPr>
+            </a:pPr>
+            <a:r>
+              <a:t>• Deploy seamlessly to the public cloud with automated CI/CD and zero license cost.</a:t>
             </a:r>
           </a:p>
         </p:txBody>
@@ -3907,7 +4740,7 @@
         <p:spPr>
           <a:xfrm>
             <a:off x="731520" y="365760"/>
-            <a:ext cx="10515600" cy="1005840"/>
+            <a:ext cx="10698480" cy="1005840"/>
           </a:xfrm>
           <a:prstGeom prst="rect">
             <a:avLst/>
@@ -3942,7 +4775,7 @@
               </a:defRPr>
             </a:pPr>
             <a:r>
-              <a:t>End-to-End Detection &amp; Scoring Architecture</a:t>
+              <a:t>System Scope: The 5-Pillar SOC Dashboard</a:t>
             </a:r>
           </a:p>
         </p:txBody>
@@ -3956,7 +4789,7 @@
         <p:spPr>
           <a:xfrm>
             <a:off x="731520" y="1645920"/>
-            <a:ext cx="10698480" cy="822960"/>
+            <a:ext cx="3383280" cy="2011680"/>
           </a:xfrm>
           <a:prstGeom prst="roundRect">
             <a:avLst/>
@@ -3989,14 +4822,17 @@
           <a:lstStyle/>
           <a:p>
             <a:pPr algn="ctr">
-              <a:defRPr sz="1400" b="1">
+              <a:spcAft>
+                <a:spcPts val="600"/>
+              </a:spcAft>
+              <a:defRPr sz="1600" b="1">
                 <a:solidFill>
                   <a:srgbClr val="00D4FF"/>
                 </a:solidFill>
               </a:defRPr>
             </a:pPr>
             <a:r>
-              <a:t>1. Data Ingestion &amp; Hygiene</a:t>
+              <a:t>01 Overview</a:t>
             </a:r>
           </a:p>
           <a:p>
@@ -4008,7 +4844,7 @@
               </a:defRPr>
             </a:pPr>
             <a:r>
-              <a:t>Normalizes 11-field canonical schema (IPs, Ports, Bytes, Protocol). Derives rolling velocity features (failed logins, unique ports, bytes per source).</a:t>
+              <a:t>KPI cards, hourly attack volume trends, severity donut, and real-time engine telemetry.</a:t>
             </a:r>
           </a:p>
         </p:txBody>
@@ -4021,8 +4857,77 @@
         </p:nvSpPr>
         <p:spPr>
           <a:xfrm>
-            <a:off x="731520" y="2606040"/>
-            <a:ext cx="10698480" cy="822960"/>
+            <a:off x="4389120" y="1645920"/>
+            <a:ext cx="3383280" cy="2011680"/>
+          </a:xfrm>
+          <a:prstGeom prst="roundRect">
+            <a:avLst/>
+          </a:prstGeom>
+          <a:solidFill>
+            <a:srgbClr val="111827"/>
+          </a:solidFill>
+          <a:ln w="19050">
+            <a:solidFill>
+              <a:srgbClr val="22C55E"/>
+            </a:solidFill>
+          </a:ln>
+        </p:spPr>
+        <p:style>
+          <a:lnRef idx="1">
+            <a:schemeClr val="accent1"/>
+          </a:lnRef>
+          <a:fillRef idx="3">
+            <a:schemeClr val="accent1"/>
+          </a:fillRef>
+          <a:effectRef idx="2">
+            <a:schemeClr val="accent1"/>
+          </a:effectRef>
+          <a:fontRef idx="minor">
+            <a:schemeClr val="lt1"/>
+          </a:fontRef>
+        </p:style>
+        <p:txBody>
+          <a:bodyPr rtlCol="0" anchor="ctr" wrap="square"/>
+          <a:lstStyle/>
+          <a:p>
+            <a:pPr algn="ctr">
+              <a:spcAft>
+                <a:spcPts val="600"/>
+              </a:spcAft>
+              <a:defRPr sz="1600" b="1">
+                <a:solidFill>
+                  <a:srgbClr val="22C55E"/>
+                </a:solidFill>
+              </a:defRPr>
+            </a:pPr>
+            <a:r>
+              <a:t>02 Log Monitoring</a:t>
+            </a:r>
+          </a:p>
+          <a:p>
+            <a:pPr>
+              <a:defRPr sz="1100">
+                <a:solidFill>
+                  <a:srgbClr val="F1F5F9"/>
+                </a:solidFill>
+              </a:defRPr>
+            </a:pPr>
+            <a:r>
+              <a:t>Searchable, filterable security log stream with protocol, date, status, and IP queries.</a:t>
+            </a:r>
+          </a:p>
+        </p:txBody>
+      </p:sp>
+      <p:sp>
+        <p:nvSpPr>
+          <p:cNvPr id="6" name="Rounded Rectangle 5"/>
+          <p:cNvSpPr/>
+          <p:nvPr/>
+        </p:nvSpPr>
+        <p:spPr>
+          <a:xfrm>
+            <a:off x="8046720" y="1645920"/>
+            <a:ext cx="3383280" cy="2011680"/>
           </a:xfrm>
           <a:prstGeom prst="roundRect">
             <a:avLst/>
@@ -4055,14 +4960,17 @@
           <a:lstStyle/>
           <a:p>
             <a:pPr algn="ctr">
-              <a:defRPr sz="1400" b="1">
+              <a:spcAft>
+                <a:spcPts val="600"/>
+              </a:spcAft>
+              <a:defRPr sz="1600" b="1">
                 <a:solidFill>
                   <a:srgbClr val="F59E0B"/>
                 </a:solidFill>
               </a:defRPr>
             </a:pPr>
             <a:r>
-              <a:t>2. Heuristic Rules Engine</a:t>
+              <a:t>03 Alert Center</a:t>
             </a:r>
           </a:p>
           <a:p>
@@ -4074,21 +4982,21 @@
               </a:defRPr>
             </a:pPr>
             <a:r>
-              <a:t>Sliding-window counters: Brute Force (&gt;5 fails in 5m), Port Scans (&gt;15 ports in 60s), and Abnormal Egress (&gt;10MB in 60s). Flags critical ports (22, 3389, 445).</a:t>
-            </a:r>
-          </a:p>
-        </p:txBody>
-      </p:sp>
-      <p:sp>
-        <p:nvSpPr>
-          <p:cNvPr id="6" name="Rounded Rectangle 5"/>
+              <a:t>Centralized triage desk, sliding-window deduplication (300s), severity filtering &amp; CSV export.</a:t>
+            </a:r>
+          </a:p>
+        </p:txBody>
+      </p:sp>
+      <p:sp>
+        <p:nvSpPr>
+          <p:cNvPr id="7" name="Rounded Rectangle 6"/>
           <p:cNvSpPr/>
           <p:nvPr/>
         </p:nvSpPr>
         <p:spPr>
           <a:xfrm>
-            <a:off x="731520" y="3566160"/>
-            <a:ext cx="10698480" cy="822960"/>
+            <a:off x="2560320" y="3931920"/>
+            <a:ext cx="3383280" cy="2011680"/>
           </a:xfrm>
           <a:prstGeom prst="roundRect">
             <a:avLst/>
@@ -4098,7 +5006,7 @@
           </a:solidFill>
           <a:ln w="19050">
             <a:solidFill>
-              <a:srgbClr val="A855F7"/>
+              <a:srgbClr val="1E40AF"/>
             </a:solidFill>
           </a:ln>
         </p:spPr>
@@ -4121,14 +5029,17 @@
           <a:lstStyle/>
           <a:p>
             <a:pPr algn="ctr">
-              <a:defRPr sz="1400" b="1">
-                <a:solidFill>
-                  <a:srgbClr val="A855F7"/>
-                </a:solidFill>
-              </a:defRPr>
-            </a:pPr>
-            <a:r>
-              <a:t>3. ML Anomaly Engine</a:t>
+              <a:spcAft>
+                <a:spcPts val="600"/>
+              </a:spcAft>
+              <a:defRPr sz="1600" b="1">
+                <a:solidFill>
+                  <a:srgbClr val="1E40AF"/>
+                </a:solidFill>
+              </a:defRPr>
+            </a:pPr>
+            <a:r>
+              <a:t>04 Analytics</a:t>
             </a:r>
           </a:p>
           <a:p>
@@ -4140,21 +5051,21 @@
               </a:defRPr>
             </a:pPr>
             <a:r>
-              <a:t>Unsupervised Isolation Forest (sklearn) trained over 4 behavioral feature dimensions to flag zero-day statistical outliers and low-and-slow breaches.</a:t>
-            </a:r>
-          </a:p>
-        </p:txBody>
-      </p:sp>
-      <p:sp>
-        <p:nvSpPr>
-          <p:cNvPr id="7" name="Rounded Rectangle 6"/>
+              <a:t>Attack surface breakdown, port targeting heatmaps (22, 80, 3389), and top offender IP rankings.</a:t>
+            </a:r>
+          </a:p>
+        </p:txBody>
+      </p:sp>
+      <p:sp>
+        <p:nvSpPr>
+          <p:cNvPr id="8" name="Rounded Rectangle 7"/>
           <p:cNvSpPr/>
           <p:nvPr/>
         </p:nvSpPr>
         <p:spPr>
           <a:xfrm>
-            <a:off x="731520" y="4526280"/>
-            <a:ext cx="10698480" cy="822960"/>
+            <a:off x="6217920" y="3931920"/>
+            <a:ext cx="3383280" cy="2011680"/>
           </a:xfrm>
           <a:prstGeom prst="roundRect">
             <a:avLst/>
@@ -4187,14 +5098,17 @@
           <a:lstStyle/>
           <a:p>
             <a:pPr algn="ctr">
-              <a:defRPr sz="1400" b="1">
+              <a:spcAft>
+                <a:spcPts val="600"/>
+              </a:spcAft>
+              <a:defRPr sz="1600" b="1">
                 <a:solidFill>
                   <a:srgbClr val="EF4444"/>
                 </a:solidFill>
               </a:defRPr>
             </a:pPr>
             <a:r>
-              <a:t>4. Risk Scoring &amp; Deduplication</a:t>
+              <a:t>05 Investigation</a:t>
             </a:r>
           </a:p>
           <a:p>
@@ -4206,73 +5120,7 @@
               </a:defRPr>
             </a:pPr>
             <a:r>
-              <a:t>Weighted CVSS-style score (0-100) combining threat category, evidence count, and critical port bonuses. Deduplicates alerts within 300s window.</a:t>
-            </a:r>
-          </a:p>
-        </p:txBody>
-      </p:sp>
-      <p:sp>
-        <p:nvSpPr>
-          <p:cNvPr id="8" name="Rounded Rectangle 7"/>
-          <p:cNvSpPr/>
-          <p:nvPr/>
-        </p:nvSpPr>
-        <p:spPr>
-          <a:xfrm>
-            <a:off x="731520" y="5486400"/>
-            <a:ext cx="10698480" cy="822960"/>
-          </a:xfrm>
-          <a:prstGeom prst="roundRect">
-            <a:avLst/>
-          </a:prstGeom>
-          <a:solidFill>
-            <a:srgbClr val="111827"/>
-          </a:solidFill>
-          <a:ln w="19050">
-            <a:solidFill>
-              <a:srgbClr val="22C55E"/>
-            </a:solidFill>
-          </a:ln>
-        </p:spPr>
-        <p:style>
-          <a:lnRef idx="1">
-            <a:schemeClr val="accent1"/>
-          </a:lnRef>
-          <a:fillRef idx="3">
-            <a:schemeClr val="accent1"/>
-          </a:fillRef>
-          <a:effectRef idx="2">
-            <a:schemeClr val="accent1"/>
-          </a:effectRef>
-          <a:fontRef idx="minor">
-            <a:schemeClr val="lt1"/>
-          </a:fontRef>
-        </p:style>
-        <p:txBody>
-          <a:bodyPr rtlCol="0" anchor="ctr" wrap="square"/>
-          <a:lstStyle/>
-          <a:p>
-            <a:pPr algn="ctr">
-              <a:defRPr sz="1400" b="1">
-                <a:solidFill>
-                  <a:srgbClr val="22C55E"/>
-                </a:solidFill>
-              </a:defRPr>
-            </a:pPr>
-            <a:r>
-              <a:t>5. Interactive SOC Dashboard</a:t>
-            </a:r>
-          </a:p>
-          <a:p>
-            <a:pPr>
-              <a:defRPr sz="1100">
-                <a:solidFill>
-                  <a:srgbClr val="F1F5F9"/>
-                </a:solidFill>
-              </a:defRPr>
-            </a:pPr>
-            <a:r>
-              <a:t>Streamlit UI with Overview KPIs, Live Log Filtering, Triage Management, ML Contamination Tuning, and Forensic IP Investigation.</a:t>
+              <a:t>Forensic workbench, MITRE ATT&amp;CK badges, dynamic Plotly CVSS gauge, timeline &amp; case notes.</a:t>
             </a:r>
           </a:p>
         </p:txBody>
@@ -4347,7 +5195,7 @@
         <p:spPr>
           <a:xfrm>
             <a:off x="731520" y="365760"/>
-            <a:ext cx="10515600" cy="1005840"/>
+            <a:ext cx="10698480" cy="1005840"/>
           </a:xfrm>
           <a:prstGeom prst="rect">
             <a:avLst/>
@@ -4382,7 +5230,7 @@
               </a:defRPr>
             </a:pPr>
             <a:r>
-              <a:t>Detection Engines: Heuristics vs. Machine Learning</a:t>
+              <a:t>Project Evolution: Key Iterations &amp; Refinements</a:t>
             </a:r>
           </a:p>
         </p:txBody>
@@ -4396,7 +5244,7 @@
         <p:spPr>
           <a:xfrm>
             <a:off x="731520" y="1645920"/>
-            <a:ext cx="5120640" cy="4572000"/>
+            <a:ext cx="10698480" cy="1005840"/>
           </a:xfrm>
           <a:prstGeom prst="roundRect">
             <a:avLst/>
@@ -4404,9 +5252,9 @@
           <a:solidFill>
             <a:srgbClr val="111827"/>
           </a:solidFill>
-          <a:ln w="19050">
+          <a:ln w="15240">
             <a:solidFill>
-              <a:srgbClr val="00D4FF"/>
+              <a:srgbClr val="EF4444"/>
             </a:solidFill>
           </a:ln>
         </p:spPr>
@@ -4430,76 +5278,28 @@
           <a:p>
             <a:pPr algn="ctr">
               <a:spcAft>
-                <a:spcPts val="1200"/>
-              </a:spcAft>
-              <a:defRPr sz="1700" b="1">
-                <a:solidFill>
-                  <a:srgbClr val="00D4FF"/>
-                </a:solidFill>
-              </a:defRPr>
-            </a:pPr>
-            <a:r>
-              <a:t>⚙️ Rule-Based Heuristic Engine</a:t>
-            </a:r>
-          </a:p>
-          <a:p>
-            <a:pPr>
-              <a:spcAft>
-                <a:spcPts val="800"/>
-              </a:spcAft>
-              <a:defRPr sz="1200">
-                <a:solidFill>
-                  <a:srgbClr val="F1F5F9"/>
-                </a:solidFill>
-              </a:defRPr>
-            </a:pPr>
-            <a:r>
-              <a:t>• Brute-Force Detector: Groups events by source_ip in 5-minute rolling windows. Flags any IP with &gt;5 failed logins.</a:t>
-            </a:r>
-          </a:p>
-          <a:p>
-            <a:pPr>
-              <a:spcAft>
-                <a:spcPts val="800"/>
-              </a:spcAft>
-              <a:defRPr sz="1200">
-                <a:solidFill>
-                  <a:srgbClr val="F1F5F9"/>
-                </a:solidFill>
-              </a:defRPr>
-            </a:pPr>
-            <a:r>
-              <a:t>• Port-Scan Detector: Identifies reconnaissance sweeps where an IP touches &gt;15 unique destination ports in 60 seconds.</a:t>
-            </a:r>
-          </a:p>
-          <a:p>
-            <a:pPr>
-              <a:spcAft>
-                <a:spcPts val="800"/>
-              </a:spcAft>
-              <a:defRPr sz="1200">
-                <a:solidFill>
-                  <a:srgbClr val="F1F5F9"/>
-                </a:solidFill>
-              </a:defRPr>
-            </a:pPr>
-            <a:r>
-              <a:t>• Abnormal Egress Detector: Flags data exfiltration spikes where total transferred bytes exceed 10 MB in a 60-second window.</a:t>
-            </a:r>
-          </a:p>
-          <a:p>
-            <a:pPr>
-              <a:spcAft>
-                <a:spcPts val="800"/>
-              </a:spcAft>
-              <a:defRPr sz="1200">
-                <a:solidFill>
-                  <a:srgbClr val="F1F5F9"/>
-                </a:solidFill>
-              </a:defRPr>
-            </a:pPr>
-            <a:r>
-              <a:t>• Deterministic &amp; Explainable: 100% precision for known threat patterns with zero black-box ambiguity.</a:t>
+                <a:spcPts val="200"/>
+              </a:spcAft>
+              <a:defRPr sz="1500" b="1">
+                <a:solidFill>
+                  <a:srgbClr val="EF4444"/>
+                </a:solidFill>
+              </a:defRPr>
+            </a:pPr>
+            <a:r>
+              <a:t>🧹 Removed Clutter</a:t>
+            </a:r>
+          </a:p>
+          <a:p>
+            <a:pPr>
+              <a:defRPr sz="1100">
+                <a:solidFill>
+                  <a:srgbClr val="F1F5F9"/>
+                </a:solidFill>
+              </a:defRPr>
+            </a:pPr>
+            <a:r>
+              <a:t>Stripped out complex 'Multi-Agent SOC' pages to keep the project dead simple, transparent, and strictly aligned with core Cloud Application Development requirements.</a:t>
             </a:r>
           </a:p>
         </p:txBody>
@@ -4512,8 +5312,8 @@
         </p:nvSpPr>
         <p:spPr>
           <a:xfrm>
-            <a:off x="6217920" y="1645920"/>
-            <a:ext cx="5120640" cy="4572000"/>
+            <a:off x="731520" y="2788920"/>
+            <a:ext cx="10698480" cy="1005840"/>
           </a:xfrm>
           <a:prstGeom prst="roundRect">
             <a:avLst/>
@@ -4521,9 +5321,9 @@
           <a:solidFill>
             <a:srgbClr val="111827"/>
           </a:solidFill>
-          <a:ln w="19050">
+          <a:ln w="15240">
             <a:solidFill>
-              <a:srgbClr val="A855F7"/>
+              <a:srgbClr val="00D4FF"/>
             </a:solidFill>
           </a:ln>
         </p:spPr>
@@ -4547,76 +5347,166 @@
           <a:p>
             <a:pPr algn="ctr">
               <a:spcAft>
-                <a:spcPts val="1200"/>
-              </a:spcAft>
-              <a:defRPr sz="1700" b="1">
-                <a:solidFill>
-                  <a:srgbClr val="A855F7"/>
-                </a:solidFill>
-              </a:defRPr>
-            </a:pPr>
-            <a:r>
-              <a:t>🤖 ML Isolation Forest Engine</a:t>
-            </a:r>
-          </a:p>
-          <a:p>
-            <a:pPr>
-              <a:spcAft>
-                <a:spcPts val="800"/>
-              </a:spcAft>
-              <a:defRPr sz="1200">
-                <a:solidFill>
-                  <a:srgbClr val="F1F5F9"/>
-                </a:solidFill>
-              </a:defRPr>
-            </a:pPr>
-            <a:r>
-              <a:t>• Unsupervised Anomaly Detection: Does not require labeled attack data; builds isolation trees on normal network baseline.</a:t>
-            </a:r>
-          </a:p>
-          <a:p>
-            <a:pPr>
-              <a:spcAft>
-                <a:spcPts val="800"/>
-              </a:spcAft>
-              <a:defRPr sz="1200">
-                <a:solidFill>
-                  <a:srgbClr val="F1F5F9"/>
-                </a:solidFill>
-              </a:defRPr>
-            </a:pPr>
-            <a:r>
-              <a:t>• Multivariate Analysis: Simultaneously evaluates failed_login_count, unique_ports_per_ip, request_rate, and bytes_per_source.</a:t>
-            </a:r>
-          </a:p>
-          <a:p>
-            <a:pPr>
-              <a:spcAft>
-                <a:spcPts val="800"/>
-              </a:spcAft>
-              <a:defRPr sz="1200">
-                <a:solidFill>
-                  <a:srgbClr val="F1F5F9"/>
-                </a:solidFill>
-              </a:defRPr>
-            </a:pPr>
-            <a:r>
-              <a:t>• Contamination Tuning: Analyst-controlled slider (0.01 - 0.20) dynamically recalibrates outlier sensitivity from the dashboard.</a:t>
-            </a:r>
-          </a:p>
-          <a:p>
-            <a:pPr>
-              <a:spcAft>
-                <a:spcPts val="800"/>
-              </a:spcAft>
-              <a:defRPr sz="1200">
-                <a:solidFill>
-                  <a:srgbClr val="F1F5F9"/>
-                </a:solidFill>
-              </a:defRPr>
-            </a:pPr>
-            <a:r>
-              <a:t>• Catches Zero-Days: Detects novel anomalous combinations that stay under individual heuristic thresholds.</a:t>
+                <a:spcPts val="200"/>
+              </a:spcAft>
+              <a:defRPr sz="1500" b="1">
+                <a:solidFill>
+                  <a:srgbClr val="00D4FF"/>
+                </a:solidFill>
+              </a:defRPr>
+            </a:pPr>
+            <a:r>
+              <a:t>🌟 Real Benchmark Telemetry</a:t>
+            </a:r>
+          </a:p>
+          <a:p>
+            <a:pPr>
+              <a:defRPr sz="1100">
+                <a:solidFill>
+                  <a:srgbClr val="F1F5F9"/>
+                </a:solidFill>
+              </a:defRPr>
+            </a:pPr>
+            <a:r>
+              <a:t>Added authentic open-source datasets: Canadian Institute for Cybersecurity (CIC-IDS2017) and AWS Cloud Honeypot attack telemetry for realistic faculty demonstrations.</a:t>
+            </a:r>
+          </a:p>
+        </p:txBody>
+      </p:sp>
+      <p:sp>
+        <p:nvSpPr>
+          <p:cNvPr id="6" name="Rounded Rectangle 5"/>
+          <p:cNvSpPr/>
+          <p:nvPr/>
+        </p:nvSpPr>
+        <p:spPr>
+          <a:xfrm>
+            <a:off x="731520" y="3931920"/>
+            <a:ext cx="10698480" cy="1005840"/>
+          </a:xfrm>
+          <a:prstGeom prst="roundRect">
+            <a:avLst/>
+          </a:prstGeom>
+          <a:solidFill>
+            <a:srgbClr val="111827"/>
+          </a:solidFill>
+          <a:ln w="15240">
+            <a:solidFill>
+              <a:srgbClr val="22C55E"/>
+            </a:solidFill>
+          </a:ln>
+        </p:spPr>
+        <p:style>
+          <a:lnRef idx="1">
+            <a:schemeClr val="accent1"/>
+          </a:lnRef>
+          <a:fillRef idx="3">
+            <a:schemeClr val="accent1"/>
+          </a:fillRef>
+          <a:effectRef idx="2">
+            <a:schemeClr val="accent1"/>
+          </a:effectRef>
+          <a:fontRef idx="minor">
+            <a:schemeClr val="lt1"/>
+          </a:fontRef>
+        </p:style>
+        <p:txBody>
+          <a:bodyPr rtlCol="0" anchor="ctr" wrap="square"/>
+          <a:lstStyle/>
+          <a:p>
+            <a:pPr algn="ctr">
+              <a:spcAft>
+                <a:spcPts val="200"/>
+              </a:spcAft>
+              <a:defRPr sz="1500" b="1">
+                <a:solidFill>
+                  <a:srgbClr val="22C55E"/>
+                </a:solidFill>
+              </a:defRPr>
+            </a:pPr>
+            <a:r>
+              <a:t>⚡ Cold-Start Self-Initialization</a:t>
+            </a:r>
+          </a:p>
+          <a:p>
+            <a:pPr>
+              <a:defRPr sz="1100">
+                <a:solidFill>
+                  <a:srgbClr val="F1F5F9"/>
+                </a:solidFill>
+              </a:defRPr>
+            </a:pPr>
+            <a:r>
+              <a:t>Implemented `ensure_session_data()` so opening direct URLs like `/Investigation-` auto-ingests benchmark telemetry with ZERO warnings, blank screens, or crashes.</a:t>
+            </a:r>
+          </a:p>
+        </p:txBody>
+      </p:sp>
+      <p:sp>
+        <p:nvSpPr>
+          <p:cNvPr id="7" name="Rounded Rectangle 6"/>
+          <p:cNvSpPr/>
+          <p:nvPr/>
+        </p:nvSpPr>
+        <p:spPr>
+          <a:xfrm>
+            <a:off x="731520" y="5074920"/>
+            <a:ext cx="10698480" cy="1005840"/>
+          </a:xfrm>
+          <a:prstGeom prst="roundRect">
+            <a:avLst/>
+          </a:prstGeom>
+          <a:solidFill>
+            <a:srgbClr val="111827"/>
+          </a:solidFill>
+          <a:ln w="15240">
+            <a:solidFill>
+              <a:srgbClr val="F59E0B"/>
+            </a:solidFill>
+          </a:ln>
+        </p:spPr>
+        <p:style>
+          <a:lnRef idx="1">
+            <a:schemeClr val="accent1"/>
+          </a:lnRef>
+          <a:fillRef idx="3">
+            <a:schemeClr val="accent1"/>
+          </a:fillRef>
+          <a:effectRef idx="2">
+            <a:schemeClr val="accent1"/>
+          </a:effectRef>
+          <a:fontRef idx="minor">
+            <a:schemeClr val="lt1"/>
+          </a:fontRef>
+        </p:style>
+        <p:txBody>
+          <a:bodyPr rtlCol="0" anchor="ctr" wrap="square"/>
+          <a:lstStyle/>
+          <a:p>
+            <a:pPr algn="ctr">
+              <a:spcAft>
+                <a:spcPts val="200"/>
+              </a:spcAft>
+              <a:defRPr sz="1500" b="1">
+                <a:solidFill>
+                  <a:srgbClr val="F59E0B"/>
+                </a:solidFill>
+              </a:defRPr>
+            </a:pPr>
+            <a:r>
+              <a:t>💾 State &amp; Disk Persistence</a:t>
+            </a:r>
+          </a:p>
+          <a:p>
+            <a:pPr>
+              <a:defRPr sz="1100">
+                <a:solidFill>
+                  <a:srgbClr val="F1F5F9"/>
+                </a:solidFill>
+              </a:defRPr>
+            </a:pPr>
+            <a:r>
+              <a:t>Synchronized in-memory session changes directly to `data/alerts.csv` on incident triage, ensuring seamless persistence across reloads and exports.</a:t>
             </a:r>
           </a:p>
         </p:txBody>
@@ -4691,7 +5581,7 @@
         <p:spPr>
           <a:xfrm>
             <a:off x="731520" y="365760"/>
-            <a:ext cx="10515600" cy="1005840"/>
+            <a:ext cx="10698480" cy="1005840"/>
           </a:xfrm>
           <a:prstGeom prst="rect">
             <a:avLst/>
@@ -4726,7 +5616,7 @@
               </a:defRPr>
             </a:pPr>
             <a:r>
-              <a:t>Dashboard Workflow: 5 Integrated Analyst Views</a:t>
+              <a:t>System Architecture &amp; Processing Pipeline</a:t>
             </a:r>
           </a:p>
         </p:txBody>
@@ -4739,8 +5629,8 @@
         </p:nvSpPr>
         <p:spPr>
           <a:xfrm>
-            <a:off x="731520" y="1645920"/>
-            <a:ext cx="10698480" cy="822960"/>
+            <a:off x="731520" y="2011680"/>
+            <a:ext cx="1920240" cy="3840480"/>
           </a:xfrm>
           <a:prstGeom prst="roundRect">
             <a:avLst/>
@@ -4773,6 +5663,9 @@
           <a:lstStyle/>
           <a:p>
             <a:pPr algn="ctr">
+              <a:spcAft>
+                <a:spcPts val="800"/>
+              </a:spcAft>
               <a:defRPr sz="1400" b="1">
                 <a:solidFill>
                   <a:srgbClr val="00D4FF"/>
@@ -4780,7 +5673,7 @@
               </a:defRPr>
             </a:pPr>
             <a:r>
-              <a:t>📊 Page 1. Overview</a:t>
+              <a:t>Step 1: Ingestion</a:t>
             </a:r>
           </a:p>
           <a:p>
@@ -4792,7 +5685,11 @@
               </a:defRPr>
             </a:pPr>
             <a:r>
-              <a:t>Executive KPIs (Total Events, Active Alerts, Critical Count, Detection Rate), Automated Threat Report, Severity Donut, and Top Offending IPs.</a:t>
+              <a:t>Raw Cloud Logs (CSV/JSON/API)</a:t>
+            </a:r>
+            <a:br/>
+            <a:r>
+              <a:t>Schema normalization to 11 standard fields.</a:t>
             </a:r>
           </a:p>
         </p:txBody>
@@ -4805,8 +5702,162 @@
         </p:nvSpPr>
         <p:spPr>
           <a:xfrm>
-            <a:off x="731520" y="2606040"/>
-            <a:ext cx="10698480" cy="822960"/>
+            <a:off x="2926080" y="2011680"/>
+            <a:ext cx="1920240" cy="3840480"/>
+          </a:xfrm>
+          <a:prstGeom prst="roundRect">
+            <a:avLst/>
+          </a:prstGeom>
+          <a:solidFill>
+            <a:srgbClr val="111827"/>
+          </a:solidFill>
+          <a:ln w="19050">
+            <a:solidFill>
+              <a:srgbClr val="1E40AF"/>
+            </a:solidFill>
+          </a:ln>
+        </p:spPr>
+        <p:style>
+          <a:lnRef idx="1">
+            <a:schemeClr val="accent1"/>
+          </a:lnRef>
+          <a:fillRef idx="3">
+            <a:schemeClr val="accent1"/>
+          </a:fillRef>
+          <a:effectRef idx="2">
+            <a:schemeClr val="accent1"/>
+          </a:effectRef>
+          <a:fontRef idx="minor">
+            <a:schemeClr val="lt1"/>
+          </a:fontRef>
+        </p:style>
+        <p:txBody>
+          <a:bodyPr rtlCol="0" anchor="ctr" wrap="square"/>
+          <a:lstStyle/>
+          <a:p>
+            <a:pPr algn="ctr">
+              <a:spcAft>
+                <a:spcPts val="800"/>
+              </a:spcAft>
+              <a:defRPr sz="1400" b="1">
+                <a:solidFill>
+                  <a:srgbClr val="1E40AF"/>
+                </a:solidFill>
+              </a:defRPr>
+            </a:pPr>
+            <a:r>
+              <a:t>Step 2: Feature Engine</a:t>
+            </a:r>
+          </a:p>
+          <a:p>
+            <a:pPr>
+              <a:defRPr sz="1100">
+                <a:solidFill>
+                  <a:srgbClr val="F1F5F9"/>
+                </a:solidFill>
+              </a:defRPr>
+            </a:pPr>
+            <a:r>
+              <a:t>Extracts velocity features:</a:t>
+            </a:r>
+            <a:br/>
+            <a:r>
+              <a:t>failed_logins, unique_ports,</a:t>
+            </a:r>
+            <a:br/>
+            <a:r>
+              <a:t>request_rate, bytes_transferred.</a:t>
+            </a:r>
+          </a:p>
+        </p:txBody>
+      </p:sp>
+      <p:sp>
+        <p:nvSpPr>
+          <p:cNvPr id="6" name="Rounded Rectangle 5"/>
+          <p:cNvSpPr/>
+          <p:nvPr/>
+        </p:nvSpPr>
+        <p:spPr>
+          <a:xfrm>
+            <a:off x="5120640" y="2011680"/>
+            <a:ext cx="1920240" cy="3840480"/>
+          </a:xfrm>
+          <a:prstGeom prst="roundRect">
+            <a:avLst/>
+          </a:prstGeom>
+          <a:solidFill>
+            <a:srgbClr val="111827"/>
+          </a:solidFill>
+          <a:ln w="19050">
+            <a:solidFill>
+              <a:srgbClr val="F59E0B"/>
+            </a:solidFill>
+          </a:ln>
+        </p:spPr>
+        <p:style>
+          <a:lnRef idx="1">
+            <a:schemeClr val="accent1"/>
+          </a:lnRef>
+          <a:fillRef idx="3">
+            <a:schemeClr val="accent1"/>
+          </a:fillRef>
+          <a:effectRef idx="2">
+            <a:schemeClr val="accent1"/>
+          </a:effectRef>
+          <a:fontRef idx="minor">
+            <a:schemeClr val="lt1"/>
+          </a:fontRef>
+        </p:style>
+        <p:txBody>
+          <a:bodyPr rtlCol="0" anchor="ctr" wrap="square"/>
+          <a:lstStyle/>
+          <a:p>
+            <a:pPr algn="ctr">
+              <a:spcAft>
+                <a:spcPts val="800"/>
+              </a:spcAft>
+              <a:defRPr sz="1400" b="1">
+                <a:solidFill>
+                  <a:srgbClr val="F59E0B"/>
+                </a:solidFill>
+              </a:defRPr>
+            </a:pPr>
+            <a:r>
+              <a:t>Step 3: Dual Engine</a:t>
+            </a:r>
+          </a:p>
+          <a:p>
+            <a:pPr>
+              <a:defRPr sz="1100">
+                <a:solidFill>
+                  <a:srgbClr val="F1F5F9"/>
+                </a:solidFill>
+              </a:defRPr>
+            </a:pPr>
+            <a:r>
+              <a:t>Branch A: Heuristic Rules</a:t>
+            </a:r>
+            <a:br/>
+            <a:r>
+              <a:t>Branch B: ML Isolation Forest</a:t>
+            </a:r>
+            <a:br/>
+            <a:r>
+              <a:t>Parallel anomaly detection.</a:t>
+            </a:r>
+          </a:p>
+        </p:txBody>
+      </p:sp>
+      <p:sp>
+        <p:nvSpPr>
+          <p:cNvPr id="7" name="Rounded Rectangle 6"/>
+          <p:cNvSpPr/>
+          <p:nvPr/>
+        </p:nvSpPr>
+        <p:spPr>
+          <a:xfrm>
+            <a:off x="7315200" y="2011680"/>
+            <a:ext cx="1920240" cy="3840480"/>
           </a:xfrm>
           <a:prstGeom prst="roundRect">
             <a:avLst/>
@@ -4839,6 +5890,9 @@
           <a:lstStyle/>
           <a:p>
             <a:pPr algn="ctr">
+              <a:spcAft>
+                <a:spcPts val="800"/>
+              </a:spcAft>
               <a:defRPr sz="1400" b="1">
                 <a:solidFill>
                   <a:srgbClr val="22C55E"/>
@@ -4846,7 +5900,7 @@
               </a:defRPr>
             </a:pPr>
             <a:r>
-              <a:t>📊 Page 2. Log Monitoring</a:t>
+              <a:t>Step 4: Risk Scoring</a:t>
             </a:r>
           </a:p>
           <a:p>
@@ -4858,21 +5912,29 @@
               </a:defRPr>
             </a:pPr>
             <a:r>
-              <a:t>Real-time auto-refreshing network telemetry stream with filters by status (Success/Failed), protocol (TCP/UDP), and time-range slider.</a:t>
-            </a:r>
-          </a:p>
-        </p:txBody>
-      </p:sp>
-      <p:sp>
-        <p:nvSpPr>
-          <p:cNvPr id="6" name="Rounded Rectangle 5"/>
+              <a:t>CVSS-style weighted scoring (0-100)</a:t>
+            </a:r>
+            <a:br/>
+            <a:r>
+              <a:t>MITRE ATT&amp;CK technique tagging</a:t>
+            </a:r>
+            <a:br/>
+            <a:r>
+              <a:t>Sliding-window deduplication.</a:t>
+            </a:r>
+          </a:p>
+        </p:txBody>
+      </p:sp>
+      <p:sp>
+        <p:nvSpPr>
+          <p:cNvPr id="8" name="Rounded Rectangle 7"/>
           <p:cNvSpPr/>
           <p:nvPr/>
         </p:nvSpPr>
         <p:spPr>
           <a:xfrm>
-            <a:off x="731520" y="3566160"/>
-            <a:ext cx="10698480" cy="822960"/>
+            <a:off x="9509760" y="2011680"/>
+            <a:ext cx="1920240" cy="3840480"/>
           </a:xfrm>
           <a:prstGeom prst="roundRect">
             <a:avLst/>
@@ -4882,7 +5944,7 @@
           </a:solidFill>
           <a:ln w="19050">
             <a:solidFill>
-              <a:srgbClr val="EF4444"/>
+              <a:srgbClr val="00D4FF"/>
             </a:solidFill>
           </a:ln>
         </p:spPr>
@@ -4905,14 +5967,17 @@
           <a:lstStyle/>
           <a:p>
             <a:pPr algn="ctr">
+              <a:spcAft>
+                <a:spcPts val="800"/>
+              </a:spcAft>
               <a:defRPr sz="1400" b="1">
                 <a:solidFill>
-                  <a:srgbClr val="EF4444"/>
-                </a:solidFill>
-              </a:defRPr>
-            </a:pPr>
-            <a:r>
-              <a:t>📊 Page 3. Alerts</a:t>
+                  <a:srgbClr val="00D4FF"/>
+                </a:solidFill>
+              </a:defRPr>
+            </a:pPr>
+            <a:r>
+              <a:t>Step 5: SOC Dashboard</a:t>
             </a:r>
           </a:p>
           <a:p>
@@ -4924,139 +5989,15 @@
               </a:defRPr>
             </a:pPr>
             <a:r>
-              <a:t>Full incident table with severity tags (CRITICAL, HIGH, MED, LOW), status lifecycle tracking (NEW -&gt; REVIEWING -&gt; RESOLVED), and CSV export.</a:t>
-            </a:r>
-          </a:p>
-        </p:txBody>
-      </p:sp>
-      <p:sp>
-        <p:nvSpPr>
-          <p:cNvPr id="7" name="Rounded Rectangle 6"/>
-          <p:cNvSpPr/>
-          <p:nvPr/>
-        </p:nvSpPr>
-        <p:spPr>
-          <a:xfrm>
-            <a:off x="731520" y="4526280"/>
-            <a:ext cx="10698480" cy="822960"/>
-          </a:xfrm>
-          <a:prstGeom prst="roundRect">
-            <a:avLst/>
-          </a:prstGeom>
-          <a:solidFill>
-            <a:srgbClr val="111827"/>
-          </a:solidFill>
-          <a:ln w="19050">
-            <a:solidFill>
-              <a:srgbClr val="A855F7"/>
-            </a:solidFill>
-          </a:ln>
-        </p:spPr>
-        <p:style>
-          <a:lnRef idx="1">
-            <a:schemeClr val="accent1"/>
-          </a:lnRef>
-          <a:fillRef idx="3">
-            <a:schemeClr val="accent1"/>
-          </a:fillRef>
-          <a:effectRef idx="2">
-            <a:schemeClr val="accent1"/>
-          </a:effectRef>
-          <a:fontRef idx="minor">
-            <a:schemeClr val="lt1"/>
-          </a:fontRef>
-        </p:style>
-        <p:txBody>
-          <a:bodyPr rtlCol="0" anchor="ctr" wrap="square"/>
-          <a:lstStyle/>
-          <a:p>
-            <a:pPr algn="ctr">
-              <a:defRPr sz="1400" b="1">
-                <a:solidFill>
-                  <a:srgbClr val="A855F7"/>
-                </a:solidFill>
-              </a:defRPr>
-            </a:pPr>
-            <a:r>
-              <a:t>📊 Page 4. Analytics</a:t>
-            </a:r>
-          </a:p>
-          <a:p>
-            <a:pPr>
-              <a:defRPr sz="1100">
-                <a:solidFill>
-                  <a:srgbClr val="F1F5F9"/>
-                </a:solidFill>
-              </a:defRPr>
-            </a:pPr>
-            <a:r>
-              <a:t>Machine learning insights: 2D/3D Isolation Forest anomaly scatter plots, feature importance bar charts, and contamination tuning slider.</a:t>
-            </a:r>
-          </a:p>
-        </p:txBody>
-      </p:sp>
-      <p:sp>
-        <p:nvSpPr>
-          <p:cNvPr id="8" name="Rounded Rectangle 7"/>
-          <p:cNvSpPr/>
-          <p:nvPr/>
-        </p:nvSpPr>
-        <p:spPr>
-          <a:xfrm>
-            <a:off x="731520" y="5486400"/>
-            <a:ext cx="10698480" cy="822960"/>
-          </a:xfrm>
-          <a:prstGeom prst="roundRect">
-            <a:avLst/>
-          </a:prstGeom>
-          <a:solidFill>
-            <a:srgbClr val="111827"/>
-          </a:solidFill>
-          <a:ln w="19050">
-            <a:solidFill>
-              <a:srgbClr val="F59E0B"/>
-            </a:solidFill>
-          </a:ln>
-        </p:spPr>
-        <p:style>
-          <a:lnRef idx="1">
-            <a:schemeClr val="accent1"/>
-          </a:lnRef>
-          <a:fillRef idx="3">
-            <a:schemeClr val="accent1"/>
-          </a:fillRef>
-          <a:effectRef idx="2">
-            <a:schemeClr val="accent1"/>
-          </a:effectRef>
-          <a:fontRef idx="minor">
-            <a:schemeClr val="lt1"/>
-          </a:fontRef>
-        </p:style>
-        <p:txBody>
-          <a:bodyPr rtlCol="0" anchor="ctr" wrap="square"/>
-          <a:lstStyle/>
-          <a:p>
-            <a:pPr algn="ctr">
-              <a:defRPr sz="1400" b="1">
-                <a:solidFill>
-                  <a:srgbClr val="F59E0B"/>
-                </a:solidFill>
-              </a:defRPr>
-            </a:pPr>
-            <a:r>
-              <a:t>📊 Page 5. Investigation</a:t>
-            </a:r>
-          </a:p>
-          <a:p>
-            <a:pPr>
-              <a:defRPr sz="1100">
-                <a:solidFill>
-                  <a:srgbClr val="F1F5F9"/>
-                </a:solidFill>
-              </a:defRPr>
-            </a:pPr>
-            <a:r>
-              <a:t>Forensic deep dive: Select any suspicious IP address to view its full chronological incident log, target port distribution, and attack timeline.</a:t>
+              <a:t>Streamlit Cloud UI</a:t>
+            </a:r>
+            <a:br/>
+            <a:r>
+              <a:t>Investigation workbench, Plotly</a:t>
+            </a:r>
+            <a:br/>
+            <a:r>
+              <a:t>charts, exportable incident dossiers.</a:t>
             </a:r>
           </a:p>
         </p:txBody>
@@ -5131,7 +6072,7 @@
         <p:spPr>
           <a:xfrm>
             <a:off x="731520" y="365760"/>
-            <a:ext cx="10515600" cy="1005840"/>
+            <a:ext cx="10698480" cy="1005840"/>
           </a:xfrm>
           <a:prstGeom prst="rect">
             <a:avLst/>
@@ -5166,7 +6107,7 @@
               </a:defRPr>
             </a:pPr>
             <a:r>
-              <a:t>Risk Scoring Methodology &amp; Deduplication</a:t>
+              <a:t>Detection Methodology: Hybrid Dual-Engine</a:t>
             </a:r>
           </a:p>
         </p:txBody>
@@ -5180,7 +6121,124 @@
         <p:spPr>
           <a:xfrm>
             <a:off x="731520" y="1645920"/>
-            <a:ext cx="10698480" cy="4572000"/>
+            <a:ext cx="5120640" cy="4572000"/>
+          </a:xfrm>
+          <a:prstGeom prst="roundRect">
+            <a:avLst/>
+          </a:prstGeom>
+          <a:solidFill>
+            <a:srgbClr val="111827"/>
+          </a:solidFill>
+          <a:ln w="19050">
+            <a:solidFill>
+              <a:srgbClr val="F59E0B"/>
+            </a:solidFill>
+          </a:ln>
+        </p:spPr>
+        <p:style>
+          <a:lnRef idx="1">
+            <a:schemeClr val="accent1"/>
+          </a:lnRef>
+          <a:fillRef idx="3">
+            <a:schemeClr val="accent1"/>
+          </a:fillRef>
+          <a:effectRef idx="2">
+            <a:schemeClr val="accent1"/>
+          </a:effectRef>
+          <a:fontRef idx="minor">
+            <a:schemeClr val="lt1"/>
+          </a:fontRef>
+        </p:style>
+        <p:txBody>
+          <a:bodyPr rtlCol="0" anchor="ctr" wrap="square"/>
+          <a:lstStyle/>
+          <a:p>
+            <a:pPr algn="ctr">
+              <a:spcAft>
+                <a:spcPts val="1000"/>
+              </a:spcAft>
+              <a:defRPr sz="1600" b="1">
+                <a:solidFill>
+                  <a:srgbClr val="F59E0B"/>
+                </a:solidFill>
+              </a:defRPr>
+            </a:pPr>
+            <a:r>
+              <a:t>⚙️ Layer 1: Deterministic Heuristic Rules</a:t>
+            </a:r>
+          </a:p>
+          <a:p>
+            <a:pPr>
+              <a:spcAft>
+                <a:spcPts val="800"/>
+              </a:spcAft>
+              <a:defRPr sz="1150">
+                <a:solidFill>
+                  <a:srgbClr val="F1F5F9"/>
+                </a:solidFill>
+              </a:defRPr>
+            </a:pPr>
+            <a:r>
+              <a:t>• SSH Brute Force: Sliding window of 300s. Flags source IPs exceeding &gt; 5 failed login attempts.</a:t>
+            </a:r>
+          </a:p>
+          <a:p>
+            <a:pPr>
+              <a:spcAft>
+                <a:spcPts val="800"/>
+              </a:spcAft>
+              <a:defRPr sz="1150">
+                <a:solidFill>
+                  <a:srgbClr val="F1F5F9"/>
+                </a:solidFill>
+              </a:defRPr>
+            </a:pPr>
+            <a:r>
+              <a:t>• Port Scan Sweep: Sliding window of 60s. Flags entities contacting &gt; 15 unique destination ports.</a:t>
+            </a:r>
+          </a:p>
+          <a:p>
+            <a:pPr>
+              <a:spcAft>
+                <a:spcPts val="800"/>
+              </a:spcAft>
+              <a:defRPr sz="1150">
+                <a:solidFill>
+                  <a:srgbClr val="F1F5F9"/>
+                </a:solidFill>
+              </a:defRPr>
+            </a:pPr>
+            <a:r>
+              <a:t>• Abnormal Volume: Sliding window of 60s. Flags bandwidth transfer exceeding &gt; 10 MB.</a:t>
+            </a:r>
+          </a:p>
+          <a:p>
+            <a:pPr>
+              <a:spcAft>
+                <a:spcPts val="800"/>
+              </a:spcAft>
+              <a:defRPr sz="1150">
+                <a:solidFill>
+                  <a:srgbClr val="F1F5F9"/>
+                </a:solidFill>
+              </a:defRPr>
+            </a:pPr>
+            <a:r>
+              <a:t>• Deterministic Clarity: Provides concrete, verifiable evidence for immediate firewall blocking.</a:t>
+            </a:r>
+          </a:p>
+        </p:txBody>
+      </p:sp>
+      <p:sp>
+        <p:nvSpPr>
+          <p:cNvPr id="5" name="Rounded Rectangle 4"/>
+          <p:cNvSpPr/>
+          <p:nvPr/>
+        </p:nvSpPr>
+        <p:spPr>
+          <a:xfrm>
+            <a:off x="6217920" y="1645920"/>
+            <a:ext cx="5120640" cy="4572000"/>
           </a:xfrm>
           <a:prstGeom prst="roundRect">
             <a:avLst/>
@@ -5214,16 +6272,16 @@
           <a:p>
             <a:pPr algn="ctr">
               <a:spcAft>
-                <a:spcPts val="1200"/>
-              </a:spcAft>
-              <a:defRPr sz="1700" b="1">
+                <a:spcPts val="1000"/>
+              </a:spcAft>
+              <a:defRPr sz="1600" b="1">
                 <a:solidFill>
                   <a:srgbClr val="00D4FF"/>
                 </a:solidFill>
               </a:defRPr>
             </a:pPr>
             <a:r>
-              <a:t>🎯 Dynamic CVSS-Style Risk Calculation Formula (0 - 100)</a:t>
+              <a:t>🤖 Layer 2: Machine Learning Isolation Forest</a:t>
             </a:r>
           </a:p>
           <a:p>
@@ -5231,14 +6289,14 @@
               <a:spcAft>
                 <a:spcPts val="800"/>
               </a:spcAft>
-              <a:defRPr sz="1300">
-                <a:solidFill>
-                  <a:srgbClr val="F1F5F9"/>
-                </a:solidFill>
-              </a:defRPr>
-            </a:pPr>
-            <a:r>
-              <a:t>• Base Score by Threat Category: Brute Force = 65 | Port Scan = 55 | Abnormal Egress = 50 | ML Anomaly = 45</a:t>
+              <a:defRPr sz="1150">
+                <a:solidFill>
+                  <a:srgbClr val="F1F5F9"/>
+                </a:solidFill>
+              </a:defRPr>
+            </a:pPr>
+            <a:r>
+              <a:t>• Unsupervised Ensemble: Scikit-learn Isolation Forest algorithm isolating sparse anomalies in multi-dimensional feature space.</a:t>
             </a:r>
           </a:p>
           <a:p>
@@ -5246,14 +6304,14 @@
               <a:spcAft>
                 <a:spcPts val="800"/>
               </a:spcAft>
-              <a:defRPr sz="1300">
-                <a:solidFill>
-                  <a:srgbClr val="F1F5F9"/>
-                </a:solidFill>
-              </a:defRPr>
-            </a:pPr>
-            <a:r>
-              <a:t>• Confidence Bonus: +15 points if detection confidence &gt; 0.80</a:t>
+              <a:defRPr sz="1150">
+                <a:solidFill>
+                  <a:srgbClr val="F1F5F9"/>
+                </a:solidFill>
+              </a:defRPr>
+            </a:pPr>
+            <a:r>
+              <a:t>• Feature Vector: X = [failed_login_count, unique_ports_per_ip, request_rate, bytes_per_source].</a:t>
             </a:r>
           </a:p>
           <a:p>
@@ -5261,14 +6319,14 @@
               <a:spcAft>
                 <a:spcPts val="800"/>
               </a:spcAft>
-              <a:defRPr sz="1300">
-                <a:solidFill>
-                  <a:srgbClr val="F1F5F9"/>
-                </a:solidFill>
-              </a:defRPr>
-            </a:pPr>
-            <a:r>
-              <a:t>• Evidence Bonus: +10 points if supporting event count &gt; 20 records</a:t>
+              <a:defRPr sz="1150">
+                <a:solidFill>
+                  <a:srgbClr val="F1F5F9"/>
+                </a:solidFill>
+              </a:defRPr>
+            </a:pPr>
+            <a:r>
+              <a:t>• Decision Function: s(x, n) = 2^(-E(h(x))/c) — anomalies isolate significantly closer to tree roots.</a:t>
             </a:r>
           </a:p>
           <a:p>
@@ -5276,59 +6334,14 @@
               <a:spcAft>
                 <a:spcPts val="800"/>
               </a:spcAft>
-              <a:defRPr sz="1300">
-                <a:solidFill>
-                  <a:srgbClr val="F1F5F9"/>
-                </a:solidFill>
-              </a:defRPr>
-            </a:pPr>
-            <a:r>
-              <a:t>• Critical Port Bonus: +10 points if target destination port is in {22 (SSH), 3389 (RDP), 445 (SMB)}</a:t>
-            </a:r>
-          </a:p>
-          <a:p>
-            <a:pPr>
-              <a:spcAft>
-                <a:spcPts val="800"/>
-              </a:spcAft>
-              <a:defRPr sz="1300">
-                <a:solidFill>
-                  <a:srgbClr val="F1F5F9"/>
-                </a:solidFill>
-              </a:defRPr>
-            </a:pPr>
-            <a:r>
-              <a:t>• Clamping &amp; Normalization: Final score clamped strictly to [0, 100]</a:t>
-            </a:r>
-          </a:p>
-          <a:p>
-            <a:pPr>
-              <a:spcAft>
-                <a:spcPts val="800"/>
-              </a:spcAft>
-              <a:defRPr sz="1300">
-                <a:solidFill>
-                  <a:srgbClr val="F1F5F9"/>
-                </a:solidFill>
-              </a:defRPr>
-            </a:pPr>
-            <a:r>
-              <a:t>• Severity Tier Mapping: LOW (0–30) | MEDIUM (31–60) | HIGH (61–80) | CRITICAL (81–100)</a:t>
-            </a:r>
-          </a:p>
-          <a:p>
-            <a:pPr>
-              <a:spcAft>
-                <a:spcPts val="800"/>
-              </a:spcAft>
-              <a:defRPr sz="1300">
-                <a:solidFill>
-                  <a:srgbClr val="F1F5F9"/>
-                </a:solidFill>
-              </a:defRPr>
-            </a:pPr>
-            <a:r>
-              <a:t>• Deduplication Window: Suppresses repeated alerts from the same IP/threat within 300 seconds to prevent analyst fatigue.</a:t>
+              <a:defRPr sz="1150">
+                <a:solidFill>
+                  <a:srgbClr val="F1F5F9"/>
+                </a:solidFill>
+              </a:defRPr>
+            </a:pPr>
+            <a:r>
+              <a:t>• Zero-Day Catching: Detects novel anomalous patterns without requiring pre-existing attack signatures.</a:t>
             </a:r>
           </a:p>
         </p:txBody>
@@ -5403,7 +6416,7 @@
         <p:spPr>
           <a:xfrm>
             <a:off x="731520" y="365760"/>
-            <a:ext cx="10515600" cy="1005840"/>
+            <a:ext cx="10698480" cy="1005840"/>
           </a:xfrm>
           <a:prstGeom prst="rect">
             <a:avLst/>
@@ -5438,7 +6451,7 @@
               </a:defRPr>
             </a:pPr>
             <a:r>
-              <a:t>Cloud Architecture &amp; Deployment Deliverables</a:t>
+              <a:t>CVSS Risk Scoring &amp; MITRE ATT&amp;CK® Alignment</a:t>
             </a:r>
           </a:p>
         </p:txBody>
@@ -5452,7 +6465,7 @@
         <p:spPr>
           <a:xfrm>
             <a:off x="731520" y="1645920"/>
-            <a:ext cx="10698480" cy="822960"/>
+            <a:ext cx="10698480" cy="2011680"/>
           </a:xfrm>
           <a:prstGeom prst="roundRect">
             <a:avLst/>
@@ -5485,26 +6498,62 @@
           <a:lstStyle/>
           <a:p>
             <a:pPr algn="ctr">
-              <a:defRPr sz="1400" b="1">
+              <a:spcAft>
+                <a:spcPts val="600"/>
+              </a:spcAft>
+              <a:defRPr sz="1600" b="1">
                 <a:solidFill>
                   <a:srgbClr val="00D4FF"/>
                 </a:solidFill>
               </a:defRPr>
             </a:pPr>
             <a:r>
-              <a:t>☁️ Containerization (Dockerfile)</a:t>
-            </a:r>
-          </a:p>
-          <a:p>
-            <a:pPr>
-              <a:defRPr sz="1100">
-                <a:solidFill>
-                  <a:srgbClr val="F1F5F9"/>
-                </a:solidFill>
-              </a:defRPr>
-            </a:pPr>
-            <a:r>
-              <a:t>Production multi-stage build using python:3.11-slim, non-root user (appuser:10001), and built-in container healthcheck probe.</a:t>
+              <a:t>🧮 Quantitative Risk Scoring Formula (0 to 100 Index)</a:t>
+            </a:r>
+          </a:p>
+          <a:p>
+            <a:pPr>
+              <a:spcAft>
+                <a:spcPts val="400"/>
+              </a:spcAft>
+              <a:defRPr sz="1200">
+                <a:solidFill>
+                  <a:srgbClr val="F1F5F9"/>
+                </a:solidFill>
+              </a:defRPr>
+            </a:pPr>
+            <a:r>
+              <a:t>• Formula: Risk Score = Clamp(Base Score + Evidence Multiplier + (Confidence × 15), 0, 100)</a:t>
+            </a:r>
+          </a:p>
+          <a:p>
+            <a:pPr>
+              <a:spcAft>
+                <a:spcPts val="400"/>
+              </a:spcAft>
+              <a:defRPr sz="1200">
+                <a:solidFill>
+                  <a:srgbClr val="F1F5F9"/>
+                </a:solidFill>
+              </a:defRPr>
+            </a:pPr>
+            <a:r>
+              <a:t>• Base Weights: Brute Force (+65) | Port Scan (+55) | Abnormal Traffic (+50) | ML Anomaly (+45)</a:t>
+            </a:r>
+          </a:p>
+          <a:p>
+            <a:pPr>
+              <a:spcAft>
+                <a:spcPts val="400"/>
+              </a:spcAft>
+              <a:defRPr sz="1200">
+                <a:solidFill>
+                  <a:srgbClr val="F1F5F9"/>
+                </a:solidFill>
+              </a:defRPr>
+            </a:pPr>
+            <a:r>
+              <a:t>• Severity Bands: LOW (0–39) | MEDIUM (40–59) | HIGH (60–79) | CRITICAL (80–100)</a:t>
             </a:r>
           </a:p>
         </p:txBody>
@@ -5517,8 +6566,8 @@
         </p:nvSpPr>
         <p:spPr>
           <a:xfrm>
-            <a:off x="731520" y="2606040"/>
-            <a:ext cx="10698480" cy="822960"/>
+            <a:off x="731520" y="3931920"/>
+            <a:ext cx="10698480" cy="2286000"/>
           </a:xfrm>
           <a:prstGeom prst="roundRect">
             <a:avLst/>
@@ -5551,224 +6600,77 @@
           <a:lstStyle/>
           <a:p>
             <a:pPr algn="ctr">
-              <a:defRPr sz="1400" b="1">
+              <a:spcAft>
+                <a:spcPts val="600"/>
+              </a:spcAft>
+              <a:defRPr sz="1600" b="1">
                 <a:solidFill>
                   <a:srgbClr val="22C55E"/>
                 </a:solidFill>
               </a:defRPr>
             </a:pPr>
             <a:r>
-              <a:t>☁️ Dynamic Port Binding (entrypoint.sh)</a:t>
-            </a:r>
-          </a:p>
-          <a:p>
-            <a:pPr>
-              <a:defRPr sz="1100">
-                <a:solidFill>
-                  <a:srgbClr val="F1F5F9"/>
-                </a:solidFill>
-              </a:defRPr>
-            </a:pPr>
-            <a:r>
-              <a:t>Eliminated localhost dependency. Automatically binds to dynamic cloud $PORT (8501 / 8000) for Render, Fly.io, and Cloud Run.</a:t>
-            </a:r>
-          </a:p>
-        </p:txBody>
-      </p:sp>
-      <p:sp>
-        <p:nvSpPr>
-          <p:cNvPr id="6" name="Rounded Rectangle 5"/>
-          <p:cNvSpPr/>
-          <p:nvPr/>
-        </p:nvSpPr>
-        <p:spPr>
-          <a:xfrm>
-            <a:off x="731520" y="3566160"/>
-            <a:ext cx="10698480" cy="822960"/>
-          </a:xfrm>
-          <a:prstGeom prst="roundRect">
-            <a:avLst/>
-          </a:prstGeom>
-          <a:solidFill>
-            <a:srgbClr val="111827"/>
-          </a:solidFill>
-          <a:ln w="19050">
-            <a:solidFill>
-              <a:srgbClr val="F59E0B"/>
-            </a:solidFill>
-          </a:ln>
-        </p:spPr>
-        <p:style>
-          <a:lnRef idx="1">
-            <a:schemeClr val="accent1"/>
-          </a:lnRef>
-          <a:fillRef idx="3">
-            <a:schemeClr val="accent1"/>
-          </a:fillRef>
-          <a:effectRef idx="2">
-            <a:schemeClr val="accent1"/>
-          </a:effectRef>
-          <a:fontRef idx="minor">
-            <a:schemeClr val="lt1"/>
-          </a:fontRef>
-        </p:style>
-        <p:txBody>
-          <a:bodyPr rtlCol="0" anchor="ctr" wrap="square"/>
-          <a:lstStyle/>
-          <a:p>
-            <a:pPr algn="ctr">
-              <a:defRPr sz="1400" b="1">
-                <a:solidFill>
-                  <a:srgbClr val="F59E0B"/>
-                </a:solidFill>
-              </a:defRPr>
-            </a:pPr>
-            <a:r>
-              <a:t>☁️ Microservices Architecture (api.py)</a:t>
-            </a:r>
-          </a:p>
-          <a:p>
-            <a:pPr>
-              <a:defRPr sz="1100">
-                <a:solidFill>
-                  <a:srgbClr val="F1F5F9"/>
-                </a:solidFill>
-              </a:defRPr>
-            </a:pPr>
-            <a:r>
-              <a:t>Decoupled Starlette/FastAPI ingestion gateway serving /healthz and /api/v1/telemetry for real-time cloud log streaming.</a:t>
-            </a:r>
-          </a:p>
-        </p:txBody>
-      </p:sp>
-      <p:sp>
-        <p:nvSpPr>
-          <p:cNvPr id="7" name="Rounded Rectangle 6"/>
-          <p:cNvSpPr/>
-          <p:nvPr/>
-        </p:nvSpPr>
-        <p:spPr>
-          <a:xfrm>
-            <a:off x="731520" y="4526280"/>
-            <a:ext cx="10698480" cy="822960"/>
-          </a:xfrm>
-          <a:prstGeom prst="roundRect">
-            <a:avLst/>
-          </a:prstGeom>
-          <a:solidFill>
-            <a:srgbClr val="111827"/>
-          </a:solidFill>
-          <a:ln w="19050">
-            <a:solidFill>
-              <a:srgbClr val="A855F7"/>
-            </a:solidFill>
-          </a:ln>
-        </p:spPr>
-        <p:style>
-          <a:lnRef idx="1">
-            <a:schemeClr val="accent1"/>
-          </a:lnRef>
-          <a:fillRef idx="3">
-            <a:schemeClr val="accent1"/>
-          </a:fillRef>
-          <a:effectRef idx="2">
-            <a:schemeClr val="accent1"/>
-          </a:effectRef>
-          <a:fontRef idx="minor">
-            <a:schemeClr val="lt1"/>
-          </a:fontRef>
-        </p:style>
-        <p:txBody>
-          <a:bodyPr rtlCol="0" anchor="ctr" wrap="square"/>
-          <a:lstStyle/>
-          <a:p>
-            <a:pPr algn="ctr">
-              <a:defRPr sz="1400" b="1">
-                <a:solidFill>
-                  <a:srgbClr val="A855F7"/>
-                </a:solidFill>
-              </a:defRPr>
-            </a:pPr>
-            <a:r>
-              <a:t>☁️ Kubernetes Manifests (k8s/)</a:t>
-            </a:r>
-          </a:p>
-          <a:p>
-            <a:pPr>
-              <a:defRPr sz="1100">
-                <a:solidFill>
-                  <a:srgbClr val="F1F5F9"/>
-                </a:solidFill>
-              </a:defRPr>
-            </a:pPr>
-            <a:r>
-              <a:t>Full production manifests: namespace.yaml, configmap.yaml, deployment.yaml, service.yaml, ingress.yaml, and HPA (Horizontal Pod Autoscaler).</a:t>
-            </a:r>
-          </a:p>
-        </p:txBody>
-      </p:sp>
-      <p:sp>
-        <p:nvSpPr>
-          <p:cNvPr id="8" name="Rounded Rectangle 7"/>
-          <p:cNvSpPr/>
-          <p:nvPr/>
-        </p:nvSpPr>
-        <p:spPr>
-          <a:xfrm>
-            <a:off x="731520" y="5486400"/>
-            <a:ext cx="10698480" cy="822960"/>
-          </a:xfrm>
-          <a:prstGeom prst="roundRect">
-            <a:avLst/>
-          </a:prstGeom>
-          <a:solidFill>
-            <a:srgbClr val="111827"/>
-          </a:solidFill>
-          <a:ln w="19050">
-            <a:solidFill>
-              <a:srgbClr val="EF4444"/>
-            </a:solidFill>
-          </a:ln>
-        </p:spPr>
-        <p:style>
-          <a:lnRef idx="1">
-            <a:schemeClr val="accent1"/>
-          </a:lnRef>
-          <a:fillRef idx="3">
-            <a:schemeClr val="accent1"/>
-          </a:fillRef>
-          <a:effectRef idx="2">
-            <a:schemeClr val="accent1"/>
-          </a:effectRef>
-          <a:fontRef idx="minor">
-            <a:schemeClr val="lt1"/>
-          </a:fontRef>
-        </p:style>
-        <p:txBody>
-          <a:bodyPr rtlCol="0" anchor="ctr" wrap="square"/>
-          <a:lstStyle/>
-          <a:p>
-            <a:pPr algn="ctr">
-              <a:defRPr sz="1400" b="1">
-                <a:solidFill>
-                  <a:srgbClr val="EF4444"/>
-                </a:solidFill>
-              </a:defRPr>
-            </a:pPr>
-            <a:r>
-              <a:t>☁️ Automated CI/CD Pipeline (.github/)</a:t>
-            </a:r>
-          </a:p>
-          <a:p>
-            <a:pPr>
-              <a:defRPr sz="1100">
-                <a:solidFill>
-                  <a:srgbClr val="F1F5F9"/>
-                </a:solidFill>
-              </a:defRPr>
-            </a:pPr>
-            <a:r>
-              <a:t>GitHub Actions workflow running flake8 linting, unittest test discovery, and automated Docker build on every push.</a:t>
+              <a:t>🛡️ MITRE ATT&amp;CK® Enterprise Matrix Mapping</a:t>
+            </a:r>
+          </a:p>
+          <a:p>
+            <a:pPr>
+              <a:spcAft>
+                <a:spcPts val="400"/>
+              </a:spcAft>
+              <a:defRPr sz="1150">
+                <a:solidFill>
+                  <a:srgbClr val="F1F5F9"/>
+                </a:solidFill>
+              </a:defRPr>
+            </a:pPr>
+            <a:r>
+              <a:t>• Brute Force ➔ T1110 (Credential Access) — Playbook: Firewall IP block, enforce MFA &amp; account lockouts.</a:t>
+            </a:r>
+          </a:p>
+          <a:p>
+            <a:pPr>
+              <a:spcAft>
+                <a:spcPts val="400"/>
+              </a:spcAft>
+              <a:defRPr sz="1150">
+                <a:solidFill>
+                  <a:srgbClr val="F1F5F9"/>
+                </a:solidFill>
+              </a:defRPr>
+            </a:pPr>
+            <a:r>
+              <a:t>• Port Scan ➔ T1046 (Network Service Discovery) — Playbook: Perimeter scanner isolation &amp; security group audit.</a:t>
+            </a:r>
+          </a:p>
+          <a:p>
+            <a:pPr>
+              <a:spcAft>
+                <a:spcPts val="400"/>
+              </a:spcAft>
+              <a:defRPr sz="1150">
+                <a:solidFill>
+                  <a:srgbClr val="F1F5F9"/>
+                </a:solidFill>
+              </a:defRPr>
+            </a:pPr>
+            <a:r>
+              <a:t>• Abnormal Traffic ➔ T1048 (Exfiltration Over Alternative Protocol) — Playbook: Connection throttling &amp; host isolation.</a:t>
+            </a:r>
+          </a:p>
+          <a:p>
+            <a:pPr>
+              <a:spcAft>
+                <a:spcPts val="400"/>
+              </a:spcAft>
+              <a:defRPr sz="1150">
+                <a:solidFill>
+                  <a:srgbClr val="F1F5F9"/>
+                </a:solidFill>
+              </a:defRPr>
+            </a:pPr>
+            <a:r>
+              <a:t>• ML Anomaly ➔ T1078 (Valid Accounts / Defense Evasion) — Playbook: Correlate host telemetry &amp; audit session tokens.</a:t>
             </a:r>
           </a:p>
         </p:txBody>
@@ -5843,7 +6745,7 @@
         <p:spPr>
           <a:xfrm>
             <a:off x="731520" y="365760"/>
-            <a:ext cx="10515600" cy="1005840"/>
+            <a:ext cx="10698480" cy="1005840"/>
           </a:xfrm>
           <a:prstGeom prst="rect">
             <a:avLst/>
@@ -5878,7 +6780,7 @@
               </a:defRPr>
             </a:pPr>
             <a:r>
-              <a:t>Experimental Results &amp; Benchmark Testing</a:t>
+              <a:t>Software Requirements &amp; Technical Stack</a:t>
             </a:r>
           </a:p>
         </p:txBody>
@@ -5892,7 +6794,7 @@
         <p:spPr>
           <a:xfrm>
             <a:off x="731520" y="1645920"/>
-            <a:ext cx="2468880" cy="1645920"/>
+            <a:ext cx="3383280" cy="2011680"/>
           </a:xfrm>
           <a:prstGeom prst="roundRect">
             <a:avLst/>
@@ -5926,28 +6828,32 @@
           <a:p>
             <a:pPr algn="ctr">
               <a:spcAft>
-                <a:spcPts val="400"/>
-              </a:spcAft>
-              <a:defRPr sz="2600" b="1">
+                <a:spcPts val="600"/>
+              </a:spcAft>
+              <a:defRPr sz="1500" b="1">
                 <a:solidFill>
                   <a:srgbClr val="00D4FF"/>
                 </a:solidFill>
               </a:defRPr>
             </a:pPr>
             <a:r>
-              <a:t>610 Events</a:t>
-            </a:r>
-          </a:p>
-          <a:p>
-            <a:pPr algn="ctr">
-              <a:defRPr sz="1200">
-                <a:solidFill>
-                  <a:srgbClr val="94A3B8"/>
-                </a:solidFill>
-              </a:defRPr>
-            </a:pPr>
-            <a:r>
-              <a:t>Telemetry Processed</a:t>
+              <a:t>Programming Language</a:t>
+            </a:r>
+          </a:p>
+          <a:p>
+            <a:pPr>
+              <a:defRPr sz="1100">
+                <a:solidFill>
+                  <a:srgbClr val="F1F5F9"/>
+                </a:solidFill>
+              </a:defRPr>
+            </a:pPr>
+            <a:r>
+              <a:t>Python 3.10+ / 3.14</a:t>
+            </a:r>
+            <a:br/>
+            <a:r>
+              <a:t>Core backend, data parsing, machine learning inference.</a:t>
             </a:r>
           </a:p>
         </p:txBody>
@@ -5960,8 +6866,81 @@
         </p:nvSpPr>
         <p:spPr>
           <a:xfrm>
-            <a:off x="3474720" y="1645920"/>
-            <a:ext cx="2468880" cy="1645920"/>
+            <a:off x="4389120" y="1645920"/>
+            <a:ext cx="3383280" cy="2011680"/>
+          </a:xfrm>
+          <a:prstGeom prst="roundRect">
+            <a:avLst/>
+          </a:prstGeom>
+          <a:solidFill>
+            <a:srgbClr val="111827"/>
+          </a:solidFill>
+          <a:ln w="19050">
+            <a:solidFill>
+              <a:srgbClr val="22C55E"/>
+            </a:solidFill>
+          </a:ln>
+        </p:spPr>
+        <p:style>
+          <a:lnRef idx="1">
+            <a:schemeClr val="accent1"/>
+          </a:lnRef>
+          <a:fillRef idx="3">
+            <a:schemeClr val="accent1"/>
+          </a:fillRef>
+          <a:effectRef idx="2">
+            <a:schemeClr val="accent1"/>
+          </a:effectRef>
+          <a:fontRef idx="minor">
+            <a:schemeClr val="lt1"/>
+          </a:fontRef>
+        </p:style>
+        <p:txBody>
+          <a:bodyPr rtlCol="0" anchor="ctr" wrap="square"/>
+          <a:lstStyle/>
+          <a:p>
+            <a:pPr algn="ctr">
+              <a:spcAft>
+                <a:spcPts val="600"/>
+              </a:spcAft>
+              <a:defRPr sz="1500" b="1">
+                <a:solidFill>
+                  <a:srgbClr val="22C55E"/>
+                </a:solidFill>
+              </a:defRPr>
+            </a:pPr>
+            <a:r>
+              <a:t>Web Framework</a:t>
+            </a:r>
+          </a:p>
+          <a:p>
+            <a:pPr>
+              <a:defRPr sz="1100">
+                <a:solidFill>
+                  <a:srgbClr val="F1F5F9"/>
+                </a:solidFill>
+              </a:defRPr>
+            </a:pPr>
+            <a:r>
+              <a:t>Streamlit (≥ 1.28)</a:t>
+            </a:r>
+            <a:br/>
+            <a:r>
+              <a:t>Reactive dark-themed SOC UI, live state &amp; components.</a:t>
+            </a:r>
+          </a:p>
+        </p:txBody>
+      </p:sp>
+      <p:sp>
+        <p:nvSpPr>
+          <p:cNvPr id="6" name="Rounded Rectangle 5"/>
+          <p:cNvSpPr/>
+          <p:nvPr/>
+        </p:nvSpPr>
+        <p:spPr>
+          <a:xfrm>
+            <a:off x="8046720" y="1645920"/>
+            <a:ext cx="3383280" cy="2011680"/>
           </a:xfrm>
           <a:prstGeom prst="roundRect">
             <a:avLst/>
@@ -5995,42 +6974,46 @@
           <a:p>
             <a:pPr algn="ctr">
               <a:spcAft>
-                <a:spcPts val="400"/>
-              </a:spcAft>
-              <a:defRPr sz="2600" b="1">
+                <a:spcPts val="600"/>
+              </a:spcAft>
+              <a:defRPr sz="1500" b="1">
                 <a:solidFill>
                   <a:srgbClr val="F59E0B"/>
                 </a:solidFill>
               </a:defRPr>
             </a:pPr>
             <a:r>
-              <a:t>9 Threats</a:t>
-            </a:r>
-          </a:p>
-          <a:p>
-            <a:pPr algn="ctr">
-              <a:defRPr sz="1200">
-                <a:solidFill>
-                  <a:srgbClr val="94A3B8"/>
-                </a:solidFill>
-              </a:defRPr>
-            </a:pPr>
-            <a:r>
-              <a:t>Alerts Flagged</a:t>
-            </a:r>
-          </a:p>
-        </p:txBody>
-      </p:sp>
-      <p:sp>
-        <p:nvSpPr>
-          <p:cNvPr id="6" name="Rounded Rectangle 5"/>
+              <a:t>Machine Learning</a:t>
+            </a:r>
+          </a:p>
+          <a:p>
+            <a:pPr>
+              <a:defRPr sz="1100">
+                <a:solidFill>
+                  <a:srgbClr val="F1F5F9"/>
+                </a:solidFill>
+              </a:defRPr>
+            </a:pPr>
+            <a:r>
+              <a:t>Scikit-Learn (≥ 1.3)</a:t>
+            </a:r>
+            <a:br/>
+            <a:r>
+              <a:t>Isolation Forest, StandardScaler, model serialization.</a:t>
+            </a:r>
+          </a:p>
+        </p:txBody>
+      </p:sp>
+      <p:sp>
+        <p:nvSpPr>
+          <p:cNvPr id="7" name="Rounded Rectangle 6"/>
           <p:cNvSpPr/>
           <p:nvPr/>
         </p:nvSpPr>
         <p:spPr>
           <a:xfrm>
-            <a:off x="6217920" y="1645920"/>
-            <a:ext cx="2468880" cy="1645920"/>
+            <a:off x="731520" y="3931920"/>
+            <a:ext cx="3383280" cy="2011680"/>
           </a:xfrm>
           <a:prstGeom prst="roundRect">
             <a:avLst/>
@@ -6040,7 +7023,7 @@
           </a:solidFill>
           <a:ln w="19050">
             <a:solidFill>
-              <a:srgbClr val="22C55E"/>
+              <a:srgbClr val="1E40AF"/>
             </a:solidFill>
           </a:ln>
         </p:spPr>
@@ -6064,42 +7047,46 @@
           <a:p>
             <a:pPr algn="ctr">
               <a:spcAft>
-                <a:spcPts val="400"/>
-              </a:spcAft>
-              <a:defRPr sz="2600" b="1">
-                <a:solidFill>
-                  <a:srgbClr val="22C55E"/>
-                </a:solidFill>
-              </a:defRPr>
-            </a:pPr>
-            <a:r>
-              <a:t>&lt; 250 ms</a:t>
-            </a:r>
-          </a:p>
-          <a:p>
-            <a:pPr algn="ctr">
-              <a:defRPr sz="1200">
-                <a:solidFill>
-                  <a:srgbClr val="94A3B8"/>
-                </a:solidFill>
-              </a:defRPr>
-            </a:pPr>
-            <a:r>
-              <a:t>Total Pipeline Latency</a:t>
-            </a:r>
-          </a:p>
-        </p:txBody>
-      </p:sp>
-      <p:sp>
-        <p:nvSpPr>
-          <p:cNvPr id="7" name="Rounded Rectangle 6"/>
+                <a:spcPts val="600"/>
+              </a:spcAft>
+              <a:defRPr sz="1500" b="1">
+                <a:solidFill>
+                  <a:srgbClr val="1E40AF"/>
+                </a:solidFill>
+              </a:defRPr>
+            </a:pPr>
+            <a:r>
+              <a:t>Data Vectorization</a:t>
+            </a:r>
+          </a:p>
+          <a:p>
+            <a:pPr>
+              <a:defRPr sz="1100">
+                <a:solidFill>
+                  <a:srgbClr val="F1F5F9"/>
+                </a:solidFill>
+              </a:defRPr>
+            </a:pPr>
+            <a:r>
+              <a:t>Pandas (≥ 2.0) &amp; NumPy</a:t>
+            </a:r>
+            <a:br/>
+            <a:r>
+              <a:t>Sliding-window resampling, telemetry normalization.</a:t>
+            </a:r>
+          </a:p>
+        </p:txBody>
+      </p:sp>
+      <p:sp>
+        <p:nvSpPr>
+          <p:cNvPr id="8" name="Rounded Rectangle 7"/>
           <p:cNvSpPr/>
           <p:nvPr/>
         </p:nvSpPr>
         <p:spPr>
           <a:xfrm>
-            <a:off x="8961120" y="1645920"/>
-            <a:ext cx="2468880" cy="1645920"/>
+            <a:off x="4389120" y="3931920"/>
+            <a:ext cx="3383280" cy="2011680"/>
           </a:xfrm>
           <a:prstGeom prst="roundRect">
             <a:avLst/>
@@ -6109,7 +7096,7 @@
           </a:solidFill>
           <a:ln w="19050">
             <a:solidFill>
-              <a:srgbClr val="A855F7"/>
+              <a:srgbClr val="EF4444"/>
             </a:solidFill>
           </a:ln>
         </p:spPr>
@@ -6133,42 +7120,46 @@
           <a:p>
             <a:pPr algn="ctr">
               <a:spcAft>
-                <a:spcPts val="400"/>
-              </a:spcAft>
-              <a:defRPr sz="2600" b="1">
-                <a:solidFill>
-                  <a:srgbClr val="A855F7"/>
-                </a:solidFill>
-              </a:defRPr>
-            </a:pPr>
-            <a:r>
-              <a:t>17 / 17 Tests</a:t>
-            </a:r>
-          </a:p>
-          <a:p>
-            <a:pPr algn="ctr">
-              <a:defRPr sz="1200">
-                <a:solidFill>
-                  <a:srgbClr val="94A3B8"/>
-                </a:solidFill>
-              </a:defRPr>
-            </a:pPr>
-            <a:r>
-              <a:t>100% Pass Rate</a:t>
-            </a:r>
-          </a:p>
-        </p:txBody>
-      </p:sp>
-      <p:sp>
-        <p:nvSpPr>
-          <p:cNvPr id="8" name="Rounded Rectangle 7"/>
+                <a:spcPts val="600"/>
+              </a:spcAft>
+              <a:defRPr sz="1500" b="1">
+                <a:solidFill>
+                  <a:srgbClr val="EF4444"/>
+                </a:solidFill>
+              </a:defRPr>
+            </a:pPr>
+            <a:r>
+              <a:t>Interactive Graphics</a:t>
+            </a:r>
+          </a:p>
+          <a:p>
+            <a:pPr>
+              <a:defRPr sz="1100">
+                <a:solidFill>
+                  <a:srgbClr val="F1F5F9"/>
+                </a:solidFill>
+              </a:defRPr>
+            </a:pPr>
+            <a:r>
+              <a:t>Plotly (≥ 5.17)</a:t>
+            </a:r>
+            <a:br/>
+            <a:r>
+              <a:t>Dynamic risk gauges, scatter attack timelines, donuts.</a:t>
+            </a:r>
+          </a:p>
+        </p:txBody>
+      </p:sp>
+      <p:sp>
+        <p:nvSpPr>
+          <p:cNvPr id="9" name="Rounded Rectangle 8"/>
           <p:cNvSpPr/>
           <p:nvPr/>
         </p:nvSpPr>
         <p:spPr>
           <a:xfrm>
-            <a:off x="731520" y="3566160"/>
-            <a:ext cx="10698480" cy="2651760"/>
+            <a:off x="8046720" y="3931920"/>
+            <a:ext cx="3383280" cy="2011680"/>
           </a:xfrm>
           <a:prstGeom prst="roundRect">
             <a:avLst/>
@@ -6178,7 +7169,7 @@
           </a:solidFill>
           <a:ln w="19050">
             <a:solidFill>
-              <a:srgbClr val="00D4FF"/>
+              <a:srgbClr val="F1F5F9"/>
             </a:solidFill>
           </a:ln>
         </p:spPr>
@@ -6202,76 +7193,32 @@
           <a:p>
             <a:pPr algn="ctr">
               <a:spcAft>
-                <a:spcPts val="1000"/>
-              </a:spcAft>
-              <a:defRPr sz="1600" b="1">
-                <a:solidFill>
-                  <a:srgbClr val="00D4FF"/>
-                </a:solidFill>
-              </a:defRPr>
-            </a:pPr>
-            <a:r>
-              <a:t>📊 Key Benchmark Findings</a:t>
-            </a:r>
-          </a:p>
-          <a:p>
-            <a:pPr>
-              <a:spcAft>
                 <a:spcPts val="600"/>
               </a:spcAft>
-              <a:defRPr sz="1200">
-                <a:solidFill>
-                  <a:srgbClr val="F1F5F9"/>
-                </a:solidFill>
-              </a:defRPr>
-            </a:pPr>
-            <a:r>
-              <a:t>• 🌟 CIC-IDS2017 Intrusion Benchmark: 726 telemetry records evaluated (SSH brute force, PortScan, and exfiltration detected with 100% precision).</a:t>
-            </a:r>
-          </a:p>
-          <a:p>
-            <a:pPr>
-              <a:spcAft>
-                <a:spcPts val="600"/>
-              </a:spcAft>
-              <a:defRPr sz="1200">
-                <a:solidFill>
-                  <a:srgbClr val="F1F5F9"/>
-                </a:solidFill>
-              </a:defRPr>
-            </a:pPr>
-            <a:r>
-              <a:t>• ☁️ AWS Cloud Honeypot Telemetry: 485 real cloud attack records triaged against port 22/3389 scans and brute force.</a:t>
-            </a:r>
-          </a:p>
-          <a:p>
-            <a:pPr>
-              <a:spcAft>
-                <a:spcPts val="600"/>
-              </a:spcAft>
-              <a:defRPr sz="1200">
-                <a:solidFill>
-                  <a:srgbClr val="F1F5F9"/>
-                </a:solidFill>
-              </a:defRPr>
-            </a:pPr>
-            <a:r>
-              <a:t>• Deterministic Rules + ML: Isolation Forest flags anomalies without fixed signatures, CVSS risk index (0-100) scores threat severity.</a:t>
-            </a:r>
-          </a:p>
-          <a:p>
-            <a:pPr>
-              <a:spcAft>
-                <a:spcPts val="600"/>
-              </a:spcAft>
-              <a:defRPr sz="1200">
-                <a:solidFill>
-                  <a:srgbClr val="F1F5F9"/>
-                </a:solidFill>
-              </a:defRPr>
-            </a:pPr>
-            <a:r>
-              <a:t>• Automated Test Suite: 17 unit tests verifying log parsing, heuristic rules, ML inference, and cloud endpoints.</a:t>
+              <a:defRPr sz="1500" b="1">
+                <a:solidFill>
+                  <a:srgbClr val="F1F5F9"/>
+                </a:solidFill>
+              </a:defRPr>
+            </a:pPr>
+            <a:r>
+              <a:t>Microservice &amp; CI/CD</a:t>
+            </a:r>
+          </a:p>
+          <a:p>
+            <a:pPr>
+              <a:defRPr sz="1100">
+                <a:solidFill>
+                  <a:srgbClr val="F1F5F9"/>
+                </a:solidFill>
+              </a:defRPr>
+            </a:pPr>
+            <a:r>
+              <a:t>Starlette &amp; Git / GitHub</a:t>
+            </a:r>
+            <a:br/>
+            <a:r>
+              <a:t>REST API gateway, continuous deployment to cloud.</a:t>
             </a:r>
           </a:p>
         </p:txBody>
@@ -6346,7 +7293,7 @@
         <p:spPr>
           <a:xfrm>
             <a:off x="731520" y="365760"/>
-            <a:ext cx="10515600" cy="1005840"/>
+            <a:ext cx="10698480" cy="1005840"/>
           </a:xfrm>
           <a:prstGeom prst="rect">
             <a:avLst/>
@@ -6381,7 +7328,7 @@
               </a:defRPr>
             </a:pPr>
             <a:r>
-              <a:t>Live Demonstration &amp; Source Repository</a:t>
+              <a:t>Cloud Deployment Strategy &amp; Architecture</a:t>
             </a:r>
           </a:p>
         </p:txBody>
@@ -6429,7 +7376,7 @@
           <a:p>
             <a:pPr algn="ctr">
               <a:spcAft>
-                <a:spcPts val="1400"/>
+                <a:spcPts val="1200"/>
               </a:spcAft>
               <a:defRPr sz="1800" b="1">
                 <a:solidFill>
@@ -6438,7 +7385,7 @@
               </a:defRPr>
             </a:pPr>
             <a:r>
-              <a:t>🌐 Live System Deployment &amp; Links</a:t>
+              <a:t>☁️ Production Cloud Infrastructure</a:t>
             </a:r>
           </a:p>
           <a:p>
@@ -6446,14 +7393,14 @@
               <a:spcAft>
                 <a:spcPts val="1000"/>
               </a:spcAft>
-              <a:defRPr sz="1300">
-                <a:solidFill>
-                  <a:srgbClr val="F1F5F9"/>
-                </a:solidFill>
-              </a:defRPr>
-            </a:pPr>
-            <a:r>
-              <a:t>• Live Web App: https://cloud-cyber-threat-detection-dashboard-sruvkhzhhjelddy9unmbhn.streamlit.app/</a:t>
+              <a:defRPr sz="1250">
+                <a:solidFill>
+                  <a:srgbClr val="F1F5F9"/>
+                </a:solidFill>
+              </a:defRPr>
+            </a:pPr>
+            <a:r>
+              <a:t>• Continuous Deployment (CI/CD): Automated deployment webhook linked to GitHub `main` branch. Any git push deploys live to Streamlit Cloud within seconds.</a:t>
             </a:r>
           </a:p>
           <a:p>
@@ -6461,14 +7408,14 @@
               <a:spcAft>
                 <a:spcPts val="1000"/>
               </a:spcAft>
-              <a:defRPr sz="1300">
-                <a:solidFill>
-                  <a:srgbClr val="F1F5F9"/>
-                </a:solidFill>
-              </a:defRPr>
-            </a:pPr>
-            <a:r>
-              <a:t>• Investigation Workbench: https://cloud-cyber-threat-detection-dashboard-sruvkhzhhjelddy9unmbhn.streamlit.app/Investigation-</a:t>
+              <a:defRPr sz="1250">
+                <a:solidFill>
+                  <a:srgbClr val="F1F5F9"/>
+                </a:solidFill>
+              </a:defRPr>
+            </a:pPr>
+            <a:r>
+              <a:t>• Containerization Ready: Includes audited production `Dockerfile` with multi-stage builds, non-root `appuser`, and automated HEALTHCHECK probes.</a:t>
             </a:r>
           </a:p>
           <a:p>
@@ -6476,14 +7423,14 @@
               <a:spcAft>
                 <a:spcPts val="1000"/>
               </a:spcAft>
-              <a:defRPr sz="1300">
-                <a:solidFill>
-                  <a:srgbClr val="F1F5F9"/>
-                </a:solidFill>
-              </a:defRPr>
-            </a:pPr>
-            <a:r>
-              <a:t>• GitHub Repository: https://github.com/Adhithya-kn/cloud-cyber-threat-detection-dashboard</a:t>
+              <a:defRPr sz="1250">
+                <a:solidFill>
+                  <a:srgbClr val="F1F5F9"/>
+                </a:solidFill>
+              </a:defRPr>
+            </a:pPr>
+            <a:r>
+              <a:t>• Kubernetes Cloud Specs: Manifests created in `k8s/` including Deployment, Service, Ingress, ConfigMap, and Horizontal Pod Autoscaler (HPA).</a:t>
             </a:r>
           </a:p>
           <a:p>
@@ -6491,14 +7438,14 @@
               <a:spcAft>
                 <a:spcPts val="1000"/>
               </a:spcAft>
-              <a:defRPr sz="1300">
-                <a:solidFill>
-                  <a:srgbClr val="F1F5F9"/>
-                </a:solidFill>
-              </a:defRPr>
-            </a:pPr>
-            <a:r>
-              <a:t>• Benchmark Datasets Included: UNB CIC-IDS2017 intrusion benchmark &amp; AWS honeypot telemetry.</a:t>
+              <a:defRPr sz="1250">
+                <a:solidFill>
+                  <a:srgbClr val="F1F5F9"/>
+                </a:solidFill>
+              </a:defRPr>
+            </a:pPr>
+            <a:r>
+              <a:t>• Edge CDN &amp; SSL: Cloudflare edge termination providing HTTPS and low-latency global delivery.</a:t>
             </a:r>
           </a:p>
           <a:p>
@@ -6506,14 +7453,14 @@
               <a:spcAft>
                 <a:spcPts val="1000"/>
               </a:spcAft>
-              <a:defRPr sz="1300">
-                <a:solidFill>
-                  <a:srgbClr val="F1F5F9"/>
-                </a:solidFill>
-              </a:defRPr>
-            </a:pPr>
-            <a:r>
-              <a:t>• Zero-Config Self-Initialization: All sub-pages auto-load benchmark telemetry with zero manual setup.</a:t>
+              <a:defRPr sz="1250">
+                <a:solidFill>
+                  <a:srgbClr val="F1F5F9"/>
+                </a:solidFill>
+              </a:defRPr>
+            </a:pPr>
+            <a:r>
+              <a:t>• Zero External License Costs: Fully self-contained architecture operating cleanly on free-tier cloud resources.</a:t>
             </a:r>
           </a:p>
         </p:txBody>

</xml_diff>